<commit_message>
adds mocks and fixtures
</commit_message>
<xml_diff>
--- a/Python/Lesson 11 - Testing/Lesson 11 - Testing.pptx
+++ b/Python/Lesson 11 - Testing/Lesson 11 - Testing.pptx
@@ -5,7 +5,7 @@
     <p:sldMasterId id="2147483673" r:id="rId1"/>
   </p:sldMasterIdLst>
   <p:notesMasterIdLst>
-    <p:notesMasterId r:id="rId24"/>
+    <p:notesMasterId r:id="rId27"/>
   </p:notesMasterIdLst>
   <p:sldIdLst>
     <p:sldId id="321" r:id="rId2"/>
@@ -26,10 +26,13 @@
     <p:sldId id="341" r:id="rId17"/>
     <p:sldId id="340" r:id="rId18"/>
     <p:sldId id="333" r:id="rId19"/>
-    <p:sldId id="329" r:id="rId20"/>
-    <p:sldId id="330" r:id="rId21"/>
-    <p:sldId id="332" r:id="rId22"/>
-    <p:sldId id="313" r:id="rId23"/>
+    <p:sldId id="343" r:id="rId20"/>
+    <p:sldId id="344" r:id="rId21"/>
+    <p:sldId id="345" r:id="rId22"/>
+    <p:sldId id="329" r:id="rId23"/>
+    <p:sldId id="346" r:id="rId24"/>
+    <p:sldId id="347" r:id="rId25"/>
+    <p:sldId id="313" r:id="rId26"/>
   </p:sldIdLst>
   <p:sldSz cx="9144000" cy="5143500" type="screen16x9"/>
   <p:notesSz cx="6858000" cy="9144000"/>
@@ -860,6 +863,279 @@
 </p:notes>
 </file>
 
+<file path=ppt/notesSlides/notesSlide3.xml><?xml version="1.0" encoding="utf-8"?>
+<p:notes xmlns:a="http://schemas.openxmlformats.org/drawingml/2006/main" xmlns:r="http://schemas.openxmlformats.org/officeDocument/2006/relationships" xmlns:p="http://schemas.openxmlformats.org/presentationml/2006/main">
+  <p:cSld>
+    <p:spTree>
+      <p:nvGrpSpPr>
+        <p:cNvPr id="1" name=""/>
+        <p:cNvGrpSpPr/>
+        <p:nvPr/>
+      </p:nvGrpSpPr>
+      <p:grpSpPr>
+        <a:xfrm>
+          <a:off x="0" y="0"/>
+          <a:ext cx="0" cy="0"/>
+          <a:chOff x="0" y="0"/>
+          <a:chExt cx="0" cy="0"/>
+        </a:xfrm>
+      </p:grpSpPr>
+      <p:sp>
+        <p:nvSpPr>
+          <p:cNvPr id="2" name="Slide Image Placeholder 1"/>
+          <p:cNvSpPr>
+            <a:spLocks noGrp="1" noRot="1" noChangeAspect="1"/>
+          </p:cNvSpPr>
+          <p:nvPr>
+            <p:ph type="sldImg"/>
+          </p:nvPr>
+        </p:nvSpPr>
+        <p:spPr>
+          <a:xfrm>
+            <a:off x="381000" y="685800"/>
+            <a:ext cx="6096000" cy="3429000"/>
+          </a:xfrm>
+        </p:spPr>
+      </p:sp>
+      <p:sp>
+        <p:nvSpPr>
+          <p:cNvPr id="3" name="Notes Placeholder 2"/>
+          <p:cNvSpPr>
+            <a:spLocks noGrp="1"/>
+          </p:cNvSpPr>
+          <p:nvPr>
+            <p:ph type="body" idx="1"/>
+          </p:nvPr>
+        </p:nvSpPr>
+        <p:spPr/>
+        <p:txBody>
+          <a:bodyPr/>
+          <a:lstStyle/>
+          <a:p>
+            <a:r>
+              <a:rPr lang="en-US" dirty="0"/>
+              <a:t>https://docs.pytest.org/en/7.1.x/how-to/fixtures.html</a:t>
+            </a:r>
+          </a:p>
+        </p:txBody>
+      </p:sp>
+    </p:spTree>
+    <p:extLst>
+      <p:ext uri="{BB962C8B-B14F-4D97-AF65-F5344CB8AC3E}">
+        <p14:creationId xmlns:p14="http://schemas.microsoft.com/office/powerpoint/2010/main" val="1523025893"/>
+      </p:ext>
+    </p:extLst>
+  </p:cSld>
+  <p:clrMapOvr>
+    <a:masterClrMapping/>
+  </p:clrMapOvr>
+</p:notes>
+</file>
+
+<file path=ppt/notesSlides/notesSlide4.xml><?xml version="1.0" encoding="utf-8"?>
+<p:notes xmlns:a="http://schemas.openxmlformats.org/drawingml/2006/main" xmlns:r="http://schemas.openxmlformats.org/officeDocument/2006/relationships" xmlns:p="http://schemas.openxmlformats.org/presentationml/2006/main">
+  <p:cSld>
+    <p:spTree>
+      <p:nvGrpSpPr>
+        <p:cNvPr id="1" name=""/>
+        <p:cNvGrpSpPr/>
+        <p:nvPr/>
+      </p:nvGrpSpPr>
+      <p:grpSpPr>
+        <a:xfrm>
+          <a:off x="0" y="0"/>
+          <a:ext cx="0" cy="0"/>
+          <a:chOff x="0" y="0"/>
+          <a:chExt cx="0" cy="0"/>
+        </a:xfrm>
+      </p:grpSpPr>
+      <p:sp>
+        <p:nvSpPr>
+          <p:cNvPr id="2" name="Slide Image Placeholder 1"/>
+          <p:cNvSpPr>
+            <a:spLocks noGrp="1" noRot="1" noChangeAspect="1"/>
+          </p:cNvSpPr>
+          <p:nvPr>
+            <p:ph type="sldImg"/>
+          </p:nvPr>
+        </p:nvSpPr>
+        <p:spPr>
+          <a:xfrm>
+            <a:off x="381000" y="685800"/>
+            <a:ext cx="6096000" cy="3429000"/>
+          </a:xfrm>
+        </p:spPr>
+      </p:sp>
+      <p:sp>
+        <p:nvSpPr>
+          <p:cNvPr id="3" name="Notes Placeholder 2"/>
+          <p:cNvSpPr>
+            <a:spLocks noGrp="1"/>
+          </p:cNvSpPr>
+          <p:nvPr>
+            <p:ph type="body" idx="1"/>
+          </p:nvPr>
+        </p:nvSpPr>
+        <p:spPr/>
+        <p:txBody>
+          <a:bodyPr/>
+          <a:lstStyle/>
+          <a:p>
+            <a:r>
+              <a:rPr lang="en-US" dirty="0"/>
+              <a:t>Fixtures are cached but side effects are not kept</a:t>
+            </a:r>
+          </a:p>
+        </p:txBody>
+      </p:sp>
+    </p:spTree>
+    <p:extLst>
+      <p:ext uri="{BB962C8B-B14F-4D97-AF65-F5344CB8AC3E}">
+        <p14:creationId xmlns:p14="http://schemas.microsoft.com/office/powerpoint/2010/main" val="7540620"/>
+      </p:ext>
+    </p:extLst>
+  </p:cSld>
+  <p:clrMapOvr>
+    <a:masterClrMapping/>
+  </p:clrMapOvr>
+</p:notes>
+</file>
+
+<file path=ppt/notesSlides/notesSlide5.xml><?xml version="1.0" encoding="utf-8"?>
+<p:notes xmlns:a="http://schemas.openxmlformats.org/drawingml/2006/main" xmlns:r="http://schemas.openxmlformats.org/officeDocument/2006/relationships" xmlns:p="http://schemas.openxmlformats.org/presentationml/2006/main">
+  <p:cSld>
+    <p:spTree>
+      <p:nvGrpSpPr>
+        <p:cNvPr id="1" name=""/>
+        <p:cNvGrpSpPr/>
+        <p:nvPr/>
+      </p:nvGrpSpPr>
+      <p:grpSpPr>
+        <a:xfrm>
+          <a:off x="0" y="0"/>
+          <a:ext cx="0" cy="0"/>
+          <a:chOff x="0" y="0"/>
+          <a:chExt cx="0" cy="0"/>
+        </a:xfrm>
+      </p:grpSpPr>
+      <p:sp>
+        <p:nvSpPr>
+          <p:cNvPr id="2" name="Slide Image Placeholder 1"/>
+          <p:cNvSpPr>
+            <a:spLocks noGrp="1" noRot="1" noChangeAspect="1"/>
+          </p:cNvSpPr>
+          <p:nvPr>
+            <p:ph type="sldImg"/>
+          </p:nvPr>
+        </p:nvSpPr>
+        <p:spPr>
+          <a:xfrm>
+            <a:off x="381000" y="685800"/>
+            <a:ext cx="6096000" cy="3429000"/>
+          </a:xfrm>
+        </p:spPr>
+      </p:sp>
+      <p:sp>
+        <p:nvSpPr>
+          <p:cNvPr id="3" name="Notes Placeholder 2"/>
+          <p:cNvSpPr>
+            <a:spLocks noGrp="1"/>
+          </p:cNvSpPr>
+          <p:nvPr>
+            <p:ph type="body" idx="1"/>
+          </p:nvPr>
+        </p:nvSpPr>
+        <p:spPr/>
+        <p:txBody>
+          <a:bodyPr/>
+          <a:lstStyle/>
+          <a:p>
+            <a:r>
+              <a:rPr lang="en-US" dirty="0"/>
+              <a:t>This fixture is shared and not created multiple times</a:t>
+            </a:r>
+          </a:p>
+        </p:txBody>
+      </p:sp>
+    </p:spTree>
+    <p:extLst>
+      <p:ext uri="{BB962C8B-B14F-4D97-AF65-F5344CB8AC3E}">
+        <p14:creationId xmlns:p14="http://schemas.microsoft.com/office/powerpoint/2010/main" val="95827445"/>
+      </p:ext>
+    </p:extLst>
+  </p:cSld>
+  <p:clrMapOvr>
+    <a:masterClrMapping/>
+  </p:clrMapOvr>
+</p:notes>
+</file>
+
+<file path=ppt/notesSlides/notesSlide6.xml><?xml version="1.0" encoding="utf-8"?>
+<p:notes xmlns:a="http://schemas.openxmlformats.org/drawingml/2006/main" xmlns:r="http://schemas.openxmlformats.org/officeDocument/2006/relationships" xmlns:p="http://schemas.openxmlformats.org/presentationml/2006/main">
+  <p:cSld>
+    <p:spTree>
+      <p:nvGrpSpPr>
+        <p:cNvPr id="1" name=""/>
+        <p:cNvGrpSpPr/>
+        <p:nvPr/>
+      </p:nvGrpSpPr>
+      <p:grpSpPr>
+        <a:xfrm>
+          <a:off x="0" y="0"/>
+          <a:ext cx="0" cy="0"/>
+          <a:chOff x="0" y="0"/>
+          <a:chExt cx="0" cy="0"/>
+        </a:xfrm>
+      </p:grpSpPr>
+      <p:sp>
+        <p:nvSpPr>
+          <p:cNvPr id="2" name="Slide Image Placeholder 1"/>
+          <p:cNvSpPr>
+            <a:spLocks noGrp="1" noRot="1" noChangeAspect="1"/>
+          </p:cNvSpPr>
+          <p:nvPr>
+            <p:ph type="sldImg"/>
+          </p:nvPr>
+        </p:nvSpPr>
+        <p:spPr>
+          <a:xfrm>
+            <a:off x="381000" y="685800"/>
+            <a:ext cx="6096000" cy="3429000"/>
+          </a:xfrm>
+        </p:spPr>
+      </p:sp>
+      <p:sp>
+        <p:nvSpPr>
+          <p:cNvPr id="3" name="Notes Placeholder 2"/>
+          <p:cNvSpPr>
+            <a:spLocks noGrp="1"/>
+          </p:cNvSpPr>
+          <p:nvPr>
+            <p:ph type="body" idx="1"/>
+          </p:nvPr>
+        </p:nvSpPr>
+        <p:spPr/>
+        <p:txBody>
+          <a:bodyPr/>
+          <a:lstStyle/>
+          <a:p>
+            <a:endParaRPr lang="en-US" dirty="0"/>
+          </a:p>
+        </p:txBody>
+      </p:sp>
+    </p:spTree>
+    <p:extLst>
+      <p:ext uri="{BB962C8B-B14F-4D97-AF65-F5344CB8AC3E}">
+        <p14:creationId xmlns:p14="http://schemas.microsoft.com/office/powerpoint/2010/main" val="1525201746"/>
+      </p:ext>
+    </p:extLst>
+  </p:cSld>
+  <p:clrMapOvr>
+    <a:masterClrMapping/>
+  </p:clrMapOvr>
+</p:notes>
+</file>
+
 <file path=ppt/slideLayouts/slideLayout1.xml><?xml version="1.0" encoding="utf-8"?>
 <p:sldLayout xmlns:a="http://schemas.openxmlformats.org/drawingml/2006/main" xmlns:r="http://schemas.openxmlformats.org/officeDocument/2006/relationships" xmlns:p="http://schemas.openxmlformats.org/presentationml/2006/main" showMasterSp="0" preserve="1" userDrawn="1">
   <p:cSld name="Title Slide">
@@ -908,7 +1184,7 @@
           <a:p>
             <a:fld id="{7A3E0868-4E26-4CDC-8A56-D70E2D8B12FE}" type="datetime3">
               <a:rPr lang="en-US" smtClean="0"/>
-              <a:t>16 June 2026</a:t>
+              <a:t>18 June 2026</a:t>
             </a:fld>
             <a:endParaRPr lang="en-US"/>
           </a:p>
@@ -3487,7 +3763,7 @@
           <a:p>
             <a:fld id="{A7B8021B-6105-4216-96FC-94348F216D0E}" type="datetime3">
               <a:rPr lang="en-US" smtClean="0"/>
-              <a:t>16 June 2026</a:t>
+              <a:t>18 June 2026</a:t>
             </a:fld>
             <a:endParaRPr lang="en-US"/>
           </a:p>
@@ -5208,7 +5484,7 @@
           <a:p>
             <a:fld id="{5D27CFAB-73E6-44A8-B862-B3306344E3F2}" type="datetime3">
               <a:rPr lang="en-US" smtClean="0"/>
-              <a:t>16 June 2026</a:t>
+              <a:t>18 June 2026</a:t>
             </a:fld>
             <a:endParaRPr lang="en-US"/>
           </a:p>
@@ -7022,7 +7298,7 @@
           <a:p>
             <a:fld id="{A9B2E784-A5F5-4301-881B-94AC8DBF9DED}" type="datetime3">
               <a:rPr lang="en-US" smtClean="0"/>
-              <a:t>16 June 2026</a:t>
+              <a:t>18 June 2026</a:t>
             </a:fld>
             <a:endParaRPr lang="en-US"/>
           </a:p>
@@ -7204,7 +7480,7 @@
           <a:p>
             <a:fld id="{18EAB3A5-9E92-4BB9-8F22-9632B4FBEDBA}" type="datetime3">
               <a:rPr lang="en-US" smtClean="0"/>
-              <a:t>16 June 2026</a:t>
+              <a:t>18 June 2026</a:t>
             </a:fld>
             <a:endParaRPr lang="en-US"/>
           </a:p>
@@ -7434,7 +7710,7 @@
           <a:p>
             <a:fld id="{40923810-5FB2-48C9-96CA-1DE2C4773142}" type="datetime3">
               <a:rPr lang="en-US" smtClean="0"/>
-              <a:t>16 June 2026</a:t>
+              <a:t>18 June 2026</a:t>
             </a:fld>
             <a:endParaRPr lang="en-US"/>
           </a:p>
@@ -7733,7 +8009,7 @@
           <a:p>
             <a:fld id="{E50EFF4B-86EB-42FB-93EA-7D8F9CB2466F}" type="datetime3">
               <a:rPr lang="en-US" smtClean="0"/>
-              <a:t>16 June 2026</a:t>
+              <a:t>18 June 2026</a:t>
             </a:fld>
             <a:endParaRPr lang="en-US"/>
           </a:p>
@@ -8363,7 +8639,7 @@
           <a:p>
             <a:fld id="{FB14FC24-E041-45E9-9A72-E5755A86890F}" type="datetime3">
               <a:rPr lang="en-US" smtClean="0"/>
-              <a:t>16 June 2026</a:t>
+              <a:t>18 June 2026</a:t>
             </a:fld>
             <a:endParaRPr lang="en-US"/>
           </a:p>
@@ -9250,7 +9526,7 @@
           <a:p>
             <a:fld id="{98A19125-94A7-4474-858C-FD9C4ABE9DDA}" type="datetime3">
               <a:rPr lang="en-US" smtClean="0"/>
-              <a:t>16 June 2026</a:t>
+              <a:t>18 June 2026</a:t>
             </a:fld>
             <a:endParaRPr lang="en-US"/>
           </a:p>
@@ -10389,7 +10665,7 @@
           <a:p>
             <a:fld id="{3BA0343D-C8D8-43CE-BB79-50DEA219DB07}" type="datetime3">
               <a:rPr lang="en-US" smtClean="0"/>
-              <a:t>16 June 2026</a:t>
+              <a:t>18 June 2026</a:t>
             </a:fld>
             <a:endParaRPr lang="en-US"/>
           </a:p>
@@ -10681,7 +10957,7 @@
           <a:p>
             <a:fld id="{453BD212-0B9F-4987-965F-AC83B2FC354F}" type="datetime3">
               <a:rPr lang="en-US" smtClean="0"/>
-              <a:t>16 June 2026</a:t>
+              <a:t>18 June 2026</a:t>
             </a:fld>
             <a:endParaRPr lang="en-US"/>
           </a:p>
@@ -10926,7 +11202,7 @@
           <a:p>
             <a:fld id="{6DDC931E-8CBE-4A3F-A034-9B6122C6DCDB}" type="datetime3">
               <a:rPr lang="en-US" smtClean="0"/>
-              <a:t>16 June 2026</a:t>
+              <a:t>18 June 2026</a:t>
             </a:fld>
             <a:endParaRPr lang="en-US"/>
           </a:p>
@@ -12704,7 +12980,7 @@
           <a:p>
             <a:fld id="{220AF9C2-5E8A-4308-AE6B-CA9B65007D0E}" type="datetime3">
               <a:rPr lang="en-US" smtClean="0"/>
-              <a:t>16 June 2026</a:t>
+              <a:t>18 June 2026</a:t>
             </a:fld>
             <a:endParaRPr lang="en-US"/>
           </a:p>
@@ -13020,7 +13296,7 @@
           <a:p>
             <a:fld id="{FF31E861-D2AF-431D-860B-DCF67C218052}" type="datetime3">
               <a:rPr lang="en-US" smtClean="0"/>
-              <a:t>16 June 2026</a:t>
+              <a:t>18 June 2026</a:t>
             </a:fld>
             <a:endParaRPr lang="en-US"/>
           </a:p>
@@ -13302,7 +13578,7 @@
           <a:p>
             <a:fld id="{D1DA25B2-AAF1-4C1F-AA38-12D5BFA7D4C8}" type="datetime3">
               <a:rPr lang="en-US" smtClean="0"/>
-              <a:t>16 June 2026</a:t>
+              <a:t>18 June 2026</a:t>
             </a:fld>
             <a:endParaRPr lang="en-US"/>
           </a:p>
@@ -13584,7 +13860,7 @@
           <a:p>
             <a:fld id="{A25C0F39-45D0-48E9-90B3-7FE8FCE561C8}" type="datetime3">
               <a:rPr lang="en-US" smtClean="0"/>
-              <a:t>16 June 2026</a:t>
+              <a:t>18 June 2026</a:t>
             </a:fld>
             <a:endParaRPr lang="en-US"/>
           </a:p>
@@ -14094,7 +14370,7 @@
           <a:p>
             <a:fld id="{9BAF1A3D-92FA-4F24-9781-74AFA516A230}" type="datetime3">
               <a:rPr lang="en-US" smtClean="0"/>
-              <a:t>16 June 2026</a:t>
+              <a:t>18 June 2026</a:t>
             </a:fld>
             <a:endParaRPr lang="en-US"/>
           </a:p>
@@ -14221,7 +14497,7 @@
           <a:p>
             <a:fld id="{5719C672-856D-4617-A693-8FE15749A9B7}" type="datetime3">
               <a:rPr lang="en-US" smtClean="0"/>
-              <a:t>16 June 2026</a:t>
+              <a:t>18 June 2026</a:t>
             </a:fld>
             <a:endParaRPr lang="en-US"/>
           </a:p>
@@ -14356,7 +14632,7 @@
           <a:p>
             <a:fld id="{5F6C764D-A39E-4C03-B161-E0BC66E8883B}" type="datetime3">
               <a:rPr lang="en-US" smtClean="0"/>
-              <a:t>16 June 2026</a:t>
+              <a:t>18 June 2026</a:t>
             </a:fld>
             <a:endParaRPr lang="en-US"/>
           </a:p>
@@ -14598,7 +14874,7 @@
           <a:p>
             <a:fld id="{6E3E33F9-20B7-4995-BE7D-165DBB597850}" type="datetime3">
               <a:rPr lang="en-US" smtClean="0"/>
-              <a:t>16 June 2026</a:t>
+              <a:t>18 June 2026</a:t>
             </a:fld>
             <a:endParaRPr lang="en-US"/>
           </a:p>
@@ -14711,7 +14987,7 @@
           <a:p>
             <a:fld id="{CD41C263-3501-4369-A962-62B6BF915CDE}" type="datetime3">
               <a:rPr lang="en-US" smtClean="0"/>
-              <a:t>16 June 2026</a:t>
+              <a:t>18 June 2026</a:t>
             </a:fld>
             <a:endParaRPr lang="en-US"/>
           </a:p>
@@ -15117,7 +15393,7 @@
           <a:p>
             <a:fld id="{B06F3EBE-B2E8-4992-9F00-9E4B44F057C0}" type="datetime3">
               <a:rPr lang="en-US" smtClean="0"/>
-              <a:t>16 June 2026</a:t>
+              <a:t>18 June 2026</a:t>
             </a:fld>
             <a:endParaRPr lang="en-US"/>
           </a:p>
@@ -15249,7 +15525,7 @@
           <a:p>
             <a:fld id="{D41656AB-D2E1-472E-8B95-0DF5C6E1D623}" type="datetime3">
               <a:rPr lang="en-US" smtClean="0"/>
-              <a:t>16 June 2026</a:t>
+              <a:t>18 June 2026</a:t>
             </a:fld>
             <a:endParaRPr lang="en-US"/>
           </a:p>
@@ -19399,7 +19675,7 @@
           <a:p>
             <a:fld id="{AD622D1A-DF83-41A8-85FF-04D90BF831D3}" type="datetime3">
               <a:rPr lang="en-US" smtClean="0"/>
-              <a:t>16 June 2026</a:t>
+              <a:t>18 June 2026</a:t>
             </a:fld>
             <a:endParaRPr lang="en-US"/>
           </a:p>
@@ -19655,7 +19931,7 @@
           <a:p>
             <a:fld id="{334F72C3-CDF3-44A8-B602-1649B1728485}" type="datetime3">
               <a:rPr lang="en-US" smtClean="0"/>
-              <a:t>16 June 2026</a:t>
+              <a:t>18 June 2026</a:t>
             </a:fld>
             <a:endParaRPr lang="en-US"/>
           </a:p>
@@ -19971,7 +20247,7 @@
           <a:p>
             <a:fld id="{1E0132BA-B5E7-4FFD-AF6C-169169D47D4A}" type="datetime3">
               <a:rPr lang="en-US" smtClean="0"/>
-              <a:t>16 June 2026</a:t>
+              <a:t>18 June 2026</a:t>
             </a:fld>
             <a:endParaRPr lang="en-US"/>
           </a:p>
@@ -20464,7 +20740,7 @@
           <a:p>
             <a:fld id="{81A30091-1C2A-4151-8D3C-D1E47A72615F}" type="datetime3">
               <a:rPr lang="en-US" smtClean="0"/>
-              <a:t>16 June 2026</a:t>
+              <a:t>18 June 2026</a:t>
             </a:fld>
             <a:endParaRPr lang="en-US"/>
           </a:p>
@@ -21125,7 +21401,7 @@
           <a:p>
             <a:fld id="{35D703CE-07B4-4C05-A488-B4566700621F}" type="datetime3">
               <a:rPr lang="en-US" smtClean="0"/>
-              <a:t>16 June 2026</a:t>
+              <a:t>18 June 2026</a:t>
             </a:fld>
             <a:endParaRPr lang="en-US"/>
           </a:p>
@@ -22195,7 +22471,7 @@
           <a:p>
             <a:fld id="{694BD61C-20BA-43AF-A21F-1DAFB3200099}" type="datetime3">
               <a:rPr lang="en-US" smtClean="0"/>
-              <a:t>16 June 2026</a:t>
+              <a:t>18 June 2026</a:t>
             </a:fld>
             <a:endParaRPr lang="en-US"/>
           </a:p>
@@ -22682,7 +22958,7 @@
           <a:p>
             <a:fld id="{CABCB1B0-B6E5-4DD1-BB55-95C076D6C0C8}" type="datetime3">
               <a:rPr lang="en-US" smtClean="0"/>
-              <a:t>16 June 2026</a:t>
+              <a:t>18 June 2026</a:t>
             </a:fld>
             <a:endParaRPr lang="en-US"/>
           </a:p>
@@ -24814,7 +25090,7 @@
           <a:p>
             <a:fld id="{334F72C3-CDF3-44A8-B602-1649B1728485}" type="datetime3">
               <a:rPr lang="en-US" smtClean="0"/>
-              <a:t>16 June 2026</a:t>
+              <a:t>18 June 2026</a:t>
             </a:fld>
             <a:endParaRPr lang="en-US"/>
           </a:p>
@@ -26042,7 +26318,7 @@
           <a:p>
             <a:fld id="{334F72C3-CDF3-44A8-B602-1649B1728485}" type="datetime3">
               <a:rPr lang="en-US" smtClean="0"/>
-              <a:t>16 June 2026</a:t>
+              <a:t>18 June 2026</a:t>
             </a:fld>
             <a:endParaRPr lang="en-US"/>
           </a:p>
@@ -26356,7 +26632,7 @@
           <a:p>
             <a:fld id="{334F72C3-CDF3-44A8-B602-1649B1728485}" type="datetime3">
               <a:rPr lang="en-US" smtClean="0"/>
-              <a:t>16 June 2026</a:t>
+              <a:t>18 June 2026</a:t>
             </a:fld>
             <a:endParaRPr lang="en-US"/>
           </a:p>
@@ -26693,7 +26969,7 @@
           <a:p>
             <a:fld id="{AD622D1A-DF83-41A8-85FF-04D90BF831D3}" type="datetime3">
               <a:rPr lang="en-US" smtClean="0"/>
-              <a:t>16 June 2026</a:t>
+              <a:t>18 June 2026</a:t>
             </a:fld>
             <a:endParaRPr lang="en-US"/>
           </a:p>
@@ -26921,7 +27197,7 @@
           <a:p>
             <a:fld id="{334F72C3-CDF3-44A8-B602-1649B1728485}" type="datetime3">
               <a:rPr lang="en-US" smtClean="0"/>
-              <a:t>16 June 2026</a:t>
+              <a:t>18 June 2026</a:t>
             </a:fld>
             <a:endParaRPr lang="en-US"/>
           </a:p>
@@ -27722,7 +27998,7 @@
           <a:p>
             <a:r>
               <a:rPr lang="en-US" dirty="0"/>
-              <a:t>What's hiding in this coverage?</a:t>
+              <a:t>What could be hiding in this coverage?</a:t>
             </a:r>
           </a:p>
         </p:txBody>
@@ -27750,7 +28026,7 @@
           <a:p>
             <a:fld id="{334F72C3-CDF3-44A8-B602-1649B1728485}" type="datetime3">
               <a:rPr lang="en-US" smtClean="0"/>
-              <a:t>16 June 2026</a:t>
+              <a:t>18 June 2026</a:t>
             </a:fld>
             <a:endParaRPr lang="en-US"/>
           </a:p>
@@ -28091,8 +28367,82 @@
           <a:p>
             <a:r>
               <a:rPr lang="en-US" dirty="0"/>
-              <a:t>Fixtures</a:t>
-            </a:r>
+              <a:t>Case 1:</a:t>
+            </a:r>
+          </a:p>
+          <a:p>
+            <a:pPr lvl="1"/>
+            <a:r>
+              <a:rPr lang="en-US" dirty="0"/>
+              <a:t>Consistent config / setup</a:t>
+            </a:r>
+          </a:p>
+          <a:p>
+            <a:pPr lvl="1"/>
+            <a:r>
+              <a:rPr lang="en-US" dirty="0"/>
+              <a:t>Consistent parameters</a:t>
+            </a:r>
+          </a:p>
+          <a:p>
+            <a:r>
+              <a:rPr lang="en-US" dirty="0"/>
+              <a:t>Case 2:</a:t>
+            </a:r>
+          </a:p>
+          <a:p>
+            <a:pPr lvl="1"/>
+            <a:r>
+              <a:rPr lang="en-US" dirty="0"/>
+              <a:t>Input data generally stays the same</a:t>
+            </a:r>
+          </a:p>
+          <a:p>
+            <a:pPr lvl="1"/>
+            <a:r>
+              <a:rPr lang="en-US" dirty="0"/>
+              <a:t>Multiple functions might need the same inputs</a:t>
+            </a:r>
+          </a:p>
+          <a:p>
+            <a:pPr lvl="1"/>
+            <a:r>
+              <a:rPr lang="en-US" dirty="0"/>
+              <a:t>Have to write the same input data for each test?</a:t>
+            </a:r>
+          </a:p>
+          <a:p>
+            <a:r>
+              <a:rPr lang="en-US" dirty="0"/>
+              <a:t>Case 3:</a:t>
+            </a:r>
+          </a:p>
+          <a:p>
+            <a:pPr lvl="1"/>
+            <a:r>
+              <a:rPr lang="en-US" dirty="0"/>
+              <a:t>Specific objects might take a while to instantiate</a:t>
+            </a:r>
+          </a:p>
+          <a:p>
+            <a:pPr lvl="1"/>
+            <a:r>
+              <a:rPr lang="en-US" dirty="0"/>
+              <a:t>We want our tests to be fast</a:t>
+            </a:r>
+          </a:p>
+          <a:p>
+            <a:pPr lvl="1"/>
+            <a:r>
+              <a:rPr lang="en-US" dirty="0"/>
+              <a:t>Preload those objects </a:t>
+            </a:r>
+          </a:p>
+          <a:p>
+            <a:endParaRPr lang="en-US" dirty="0"/>
+          </a:p>
+          <a:p>
+            <a:endParaRPr lang="en-US" dirty="0"/>
           </a:p>
         </p:txBody>
       </p:sp>
@@ -28119,7 +28469,7 @@
           <a:p>
             <a:fld id="{AD622D1A-DF83-41A8-85FF-04D90BF831D3}" type="datetime3">
               <a:rPr lang="en-US" smtClean="0"/>
-              <a:t>16 June 2026</a:t>
+              <a:t>18 June 2026</a:t>
             </a:fld>
             <a:endParaRPr lang="en-US"/>
           </a:p>
@@ -28190,7 +28540,7 @@
           <p:cNvPr id="2" name="Title 1">
             <a:extLst>
               <a:ext uri="{FF2B5EF4-FFF2-40B4-BE49-F238E27FC236}">
-                <a16:creationId xmlns:a16="http://schemas.microsoft.com/office/drawing/2014/main" id="{1E90BFE8-BEA7-3940-667B-3FF6A7BCDE23}"/>
+                <a16:creationId xmlns:a16="http://schemas.microsoft.com/office/drawing/2014/main" id="{914E8921-BD4D-5B6E-2FBA-F2836DE0BD9D}"/>
               </a:ext>
             </a:extLst>
           </p:cNvPr>
@@ -28208,22 +28558,49 @@
           <a:p>
             <a:r>
               <a:rPr lang="en-US" dirty="0"/>
-              <a:t>Mocking </a:t>
-            </a:r>
-            <a:r>
-              <a:rPr lang="en-US"/>
-              <a:t>External References</a:t>
-            </a:r>
-            <a:endParaRPr lang="en-US" dirty="0"/>
-          </a:p>
-        </p:txBody>
-      </p:sp>
-      <p:sp>
-        <p:nvSpPr>
-          <p:cNvPr id="3" name="Content Placeholder 2">
-            <a:extLst>
-              <a:ext uri="{FF2B5EF4-FFF2-40B4-BE49-F238E27FC236}">
-                <a16:creationId xmlns:a16="http://schemas.microsoft.com/office/drawing/2014/main" id="{3DFA01B0-9D70-8BBB-8D34-48A2E2EF3701}"/>
+              <a:t>Fixtures</a:t>
+            </a:r>
+          </a:p>
+        </p:txBody>
+      </p:sp>
+      <p:pic>
+        <p:nvPicPr>
+          <p:cNvPr id="7" name="Content Placeholder 6">
+            <a:extLst>
+              <a:ext uri="{FF2B5EF4-FFF2-40B4-BE49-F238E27FC236}">
+                <a16:creationId xmlns:a16="http://schemas.microsoft.com/office/drawing/2014/main" id="{3762C841-FABF-D46F-FC8F-616B8BE6BE0B}"/>
+              </a:ext>
+            </a:extLst>
+          </p:cNvPr>
+          <p:cNvPicPr>
+            <a:picLocks noGrp="1" noChangeAspect="1"/>
+          </p:cNvPicPr>
+          <p:nvPr>
+            <p:ph idx="1"/>
+          </p:nvPr>
+        </p:nvPicPr>
+        <p:blipFill>
+          <a:blip r:embed="rId3"/>
+          <a:stretch>
+            <a:fillRect/>
+          </a:stretch>
+        </p:blipFill>
+        <p:spPr>
+          <a:xfrm>
+            <a:off x="827365" y="1052454"/>
+            <a:ext cx="7115988" cy="3358480"/>
+          </a:xfrm>
+          <a:prstGeom prst="rect">
+            <a:avLst/>
+          </a:prstGeom>
+        </p:spPr>
+      </p:pic>
+      <p:sp>
+        <p:nvSpPr>
+          <p:cNvPr id="4" name="Date Placeholder 3">
+            <a:extLst>
+              <a:ext uri="{FF2B5EF4-FFF2-40B4-BE49-F238E27FC236}">
+                <a16:creationId xmlns:a16="http://schemas.microsoft.com/office/drawing/2014/main" id="{DE0531EB-F71B-5C5F-1F1F-F121CA1CD462}"/>
               </a:ext>
             </a:extLst>
           </p:cNvPr>
@@ -28231,7 +28608,7 @@
             <a:spLocks noGrp="1"/>
           </p:cNvSpPr>
           <p:nvPr>
-            <p:ph idx="1"/>
+            <p:ph type="dt" sz="half" idx="10"/>
           </p:nvPr>
         </p:nvSpPr>
         <p:spPr/>
@@ -28239,37 +28616,9 @@
           <a:bodyPr/>
           <a:lstStyle/>
           <a:p>
-            <a:r>
-              <a:rPr lang="en-US" dirty="0"/>
-              <a:t>Intro to mocks</a:t>
-            </a:r>
-          </a:p>
-        </p:txBody>
-      </p:sp>
-      <p:sp>
-        <p:nvSpPr>
-          <p:cNvPr id="4" name="Date Placeholder 3">
-            <a:extLst>
-              <a:ext uri="{FF2B5EF4-FFF2-40B4-BE49-F238E27FC236}">
-                <a16:creationId xmlns:a16="http://schemas.microsoft.com/office/drawing/2014/main" id="{4FFB9305-2CBA-FCFF-86FC-1A2D6F2DCA86}"/>
-              </a:ext>
-            </a:extLst>
-          </p:cNvPr>
-          <p:cNvSpPr>
-            <a:spLocks noGrp="1"/>
-          </p:cNvSpPr>
-          <p:nvPr>
-            <p:ph type="dt" sz="half" idx="10"/>
-          </p:nvPr>
-        </p:nvSpPr>
-        <p:spPr/>
-        <p:txBody>
-          <a:bodyPr/>
-          <a:lstStyle/>
-          <a:p>
             <a:fld id="{AD622D1A-DF83-41A8-85FF-04D90BF831D3}" type="datetime3">
               <a:rPr lang="en-US" smtClean="0"/>
-              <a:t>16 June 2026</a:t>
+              <a:t>18 June 2026</a:t>
             </a:fld>
             <a:endParaRPr lang="en-US"/>
           </a:p>
@@ -28280,7 +28629,7 @@
           <p:cNvPr id="5" name="Slide Number Placeholder 4">
             <a:extLst>
               <a:ext uri="{FF2B5EF4-FFF2-40B4-BE49-F238E27FC236}">
-                <a16:creationId xmlns:a16="http://schemas.microsoft.com/office/drawing/2014/main" id="{BC24ECD0-6721-C76E-C7B4-37CC4871FADC}"/>
+                <a16:creationId xmlns:a16="http://schemas.microsoft.com/office/drawing/2014/main" id="{D5A70CB1-4188-AD39-4290-CCF8E0598AC4}"/>
               </a:ext>
             </a:extLst>
           </p:cNvPr>
@@ -28308,7 +28657,7 @@
     </p:spTree>
     <p:extLst>
       <p:ext uri="{BB962C8B-B14F-4D97-AF65-F5344CB8AC3E}">
-        <p14:creationId xmlns:p14="http://schemas.microsoft.com/office/powerpoint/2010/main" val="1276382243"/>
+        <p14:creationId xmlns:p14="http://schemas.microsoft.com/office/powerpoint/2010/main" val="3139033530"/>
       </p:ext>
     </p:extLst>
   </p:cSld>
@@ -28432,7 +28781,7 @@
           <a:p>
             <a:fld id="{D41656AB-D2E1-472E-8B95-0DF5C6E1D623}" type="datetime3">
               <a:rPr lang="en-US" smtClean="0"/>
-              <a:t>16 June 2026</a:t>
+              <a:t>18 June 2026</a:t>
             </a:fld>
             <a:endParaRPr lang="en-US"/>
           </a:p>
@@ -28486,13 +28835,7 @@
   <p:cSld>
     <p:spTree>
       <p:nvGrpSpPr>
-        <p:cNvPr id="1" name="">
-          <a:extLst>
-            <a:ext uri="{FF2B5EF4-FFF2-40B4-BE49-F238E27FC236}">
-              <a16:creationId xmlns:a16="http://schemas.microsoft.com/office/drawing/2014/main" id="{324DADAD-76BA-9AB6-04D8-F96359438996}"/>
-            </a:ext>
-          </a:extLst>
-        </p:cNvPr>
+        <p:cNvPr id="1" name=""/>
         <p:cNvGrpSpPr/>
         <p:nvPr/>
       </p:nvGrpSpPr>
@@ -28506,10 +28849,10 @@
       </p:grpSpPr>
       <p:sp>
         <p:nvSpPr>
-          <p:cNvPr id="19" name="Title 18">
-            <a:extLst>
-              <a:ext uri="{FF2B5EF4-FFF2-40B4-BE49-F238E27FC236}">
-                <a16:creationId xmlns:a16="http://schemas.microsoft.com/office/drawing/2014/main" id="{36B38081-0A20-1671-69BB-F04D160E86DA}"/>
+          <p:cNvPr id="2" name="Title 1">
+            <a:extLst>
+              <a:ext uri="{FF2B5EF4-FFF2-40B4-BE49-F238E27FC236}">
+                <a16:creationId xmlns:a16="http://schemas.microsoft.com/office/drawing/2014/main" id="{B70DDD1B-F3B0-F59F-345F-5D1C7D0E0D71}"/>
               </a:ext>
             </a:extLst>
           </p:cNvPr>
@@ -28517,7 +28860,7 @@
             <a:spLocks noGrp="1"/>
           </p:cNvSpPr>
           <p:nvPr>
-            <p:ph type="ctrTitle"/>
+            <p:ph type="title"/>
           </p:nvPr>
         </p:nvSpPr>
         <p:spPr/>
@@ -28527,17 +28870,49 @@
           <a:p>
             <a:r>
               <a:rPr lang="en-US" dirty="0"/>
-              <a:t>Integration Tests</a:t>
-            </a:r>
-          </a:p>
-        </p:txBody>
-      </p:sp>
-      <p:sp>
-        <p:nvSpPr>
-          <p:cNvPr id="20" name="Subtitle 19">
-            <a:extLst>
-              <a:ext uri="{FF2B5EF4-FFF2-40B4-BE49-F238E27FC236}">
-                <a16:creationId xmlns:a16="http://schemas.microsoft.com/office/drawing/2014/main" id="{3BA15F1A-B579-CF67-3060-C51EA22FB5C8}"/>
+              <a:t>Fixtures</a:t>
+            </a:r>
+          </a:p>
+        </p:txBody>
+      </p:sp>
+      <p:pic>
+        <p:nvPicPr>
+          <p:cNvPr id="7" name="Content Placeholder 6">
+            <a:extLst>
+              <a:ext uri="{FF2B5EF4-FFF2-40B4-BE49-F238E27FC236}">
+                <a16:creationId xmlns:a16="http://schemas.microsoft.com/office/drawing/2014/main" id="{EB2174EE-2812-2F22-76C8-97935FAF6293}"/>
+              </a:ext>
+            </a:extLst>
+          </p:cNvPr>
+          <p:cNvPicPr>
+            <a:picLocks noGrp="1" noChangeAspect="1"/>
+          </p:cNvPicPr>
+          <p:nvPr>
+            <p:ph idx="1"/>
+          </p:nvPr>
+        </p:nvPicPr>
+        <p:blipFill>
+          <a:blip r:embed="rId3"/>
+          <a:stretch>
+            <a:fillRect/>
+          </a:stretch>
+        </p:blipFill>
+        <p:spPr>
+          <a:xfrm>
+            <a:off x="3129373" y="79031"/>
+            <a:ext cx="6014627" cy="4985437"/>
+          </a:xfrm>
+          <a:prstGeom prst="rect">
+            <a:avLst/>
+          </a:prstGeom>
+        </p:spPr>
+      </p:pic>
+      <p:sp>
+        <p:nvSpPr>
+          <p:cNvPr id="4" name="Date Placeholder 3">
+            <a:extLst>
+              <a:ext uri="{FF2B5EF4-FFF2-40B4-BE49-F238E27FC236}">
+                <a16:creationId xmlns:a16="http://schemas.microsoft.com/office/drawing/2014/main" id="{ABCBFB7D-B32A-FBF3-D5F5-F1CD4FC149EC}"/>
               </a:ext>
             </a:extLst>
           </p:cNvPr>
@@ -28545,7 +28920,7 @@
             <a:spLocks noGrp="1"/>
           </p:cNvSpPr>
           <p:nvPr>
-            <p:ph type="subTitle" idx="1"/>
+            <p:ph type="dt" sz="half" idx="10"/>
           </p:nvPr>
         </p:nvSpPr>
         <p:spPr/>
@@ -28553,34 +28928,9 @@
           <a:bodyPr/>
           <a:lstStyle/>
           <a:p>
-            <a:endParaRPr lang="en-US"/>
-          </a:p>
-        </p:txBody>
-      </p:sp>
-      <p:sp>
-        <p:nvSpPr>
-          <p:cNvPr id="4" name="Date Placeholder 3">
-            <a:extLst>
-              <a:ext uri="{FF2B5EF4-FFF2-40B4-BE49-F238E27FC236}">
-                <a16:creationId xmlns:a16="http://schemas.microsoft.com/office/drawing/2014/main" id="{5EC030FD-2B80-BD4D-BA09-0A7A49C2BA76}"/>
-              </a:ext>
-            </a:extLst>
-          </p:cNvPr>
-          <p:cNvSpPr>
-            <a:spLocks noGrp="1"/>
-          </p:cNvSpPr>
-          <p:nvPr>
-            <p:ph type="dt" idx="10"/>
-          </p:nvPr>
-        </p:nvSpPr>
-        <p:spPr/>
-        <p:txBody>
-          <a:bodyPr/>
-          <a:lstStyle/>
-          <a:p>
             <a:fld id="{AD622D1A-DF83-41A8-85FF-04D90BF831D3}" type="datetime3">
               <a:rPr lang="en-US" smtClean="0"/>
-              <a:t>16 June 2026</a:t>
+              <a:t>18 June 2026</a:t>
             </a:fld>
             <a:endParaRPr lang="en-US"/>
           </a:p>
@@ -28591,7 +28941,7 @@
           <p:cNvPr id="5" name="Slide Number Placeholder 4">
             <a:extLst>
               <a:ext uri="{FF2B5EF4-FFF2-40B4-BE49-F238E27FC236}">
-                <a16:creationId xmlns:a16="http://schemas.microsoft.com/office/drawing/2014/main" id="{031F3622-C14B-8E9D-151C-66C2F0F036A0}"/>
+                <a16:creationId xmlns:a16="http://schemas.microsoft.com/office/drawing/2014/main" id="{CE8089C0-371A-E4C3-77BB-56B809D2E5A0}"/>
               </a:ext>
             </a:extLst>
           </p:cNvPr>
@@ -28599,7 +28949,7 @@
             <a:spLocks noGrp="1"/>
           </p:cNvSpPr>
           <p:nvPr>
-            <p:ph type="sldNum" idx="12"/>
+            <p:ph type="sldNum" sz="quarter" idx="11"/>
           </p:nvPr>
         </p:nvSpPr>
         <p:spPr/>
@@ -28619,7 +28969,7 @@
     </p:spTree>
     <p:extLst>
       <p:ext uri="{BB962C8B-B14F-4D97-AF65-F5344CB8AC3E}">
-        <p14:creationId xmlns:p14="http://schemas.microsoft.com/office/powerpoint/2010/main" val="1145013977"/>
+        <p14:creationId xmlns:p14="http://schemas.microsoft.com/office/powerpoint/2010/main" val="2828358992"/>
       </p:ext>
     </p:extLst>
   </p:cSld>
@@ -28648,10 +28998,10 @@
       </p:grpSpPr>
       <p:sp>
         <p:nvSpPr>
-          <p:cNvPr id="7" name="Title 6">
-            <a:extLst>
-              <a:ext uri="{FF2B5EF4-FFF2-40B4-BE49-F238E27FC236}">
-                <a16:creationId xmlns:a16="http://schemas.microsoft.com/office/drawing/2014/main" id="{D14BFEEE-7A67-A4C6-34AC-EBA551105650}"/>
+          <p:cNvPr id="2" name="Title 1">
+            <a:extLst>
+              <a:ext uri="{FF2B5EF4-FFF2-40B4-BE49-F238E27FC236}">
+                <a16:creationId xmlns:a16="http://schemas.microsoft.com/office/drawing/2014/main" id="{4877FFEF-2D47-84E3-5D79-E149C8FAB2EB}"/>
               </a:ext>
             </a:extLst>
           </p:cNvPr>
@@ -28667,16 +29017,19 @@
           <a:bodyPr/>
           <a:lstStyle/>
           <a:p>
-            <a:endParaRPr lang="en-US"/>
-          </a:p>
-        </p:txBody>
-      </p:sp>
-      <p:sp>
-        <p:nvSpPr>
-          <p:cNvPr id="8" name="Content Placeholder 7">
-            <a:extLst>
-              <a:ext uri="{FF2B5EF4-FFF2-40B4-BE49-F238E27FC236}">
-                <a16:creationId xmlns:a16="http://schemas.microsoft.com/office/drawing/2014/main" id="{C56C219E-137A-78B0-B87B-03012C100723}"/>
+            <a:r>
+              <a:rPr lang="en-US" dirty="0"/>
+              <a:t>Fixtures</a:t>
+            </a:r>
+          </a:p>
+        </p:txBody>
+      </p:sp>
+      <p:sp>
+        <p:nvSpPr>
+          <p:cNvPr id="4" name="Date Placeholder 3">
+            <a:extLst>
+              <a:ext uri="{FF2B5EF4-FFF2-40B4-BE49-F238E27FC236}">
+                <a16:creationId xmlns:a16="http://schemas.microsoft.com/office/drawing/2014/main" id="{54EBD7C6-0C9A-08C8-D1BA-911281F6AF5F}"/>
               </a:ext>
             </a:extLst>
           </p:cNvPr>
@@ -28684,7 +29037,7 @@
             <a:spLocks noGrp="1"/>
           </p:cNvSpPr>
           <p:nvPr>
-            <p:ph idx="1"/>
+            <p:ph type="dt" sz="half" idx="10"/>
           </p:nvPr>
         </p:nvSpPr>
         <p:spPr/>
@@ -28692,19 +29045,20 @@
           <a:bodyPr/>
           <a:lstStyle/>
           <a:p>
-            <a:r>
-              <a:rPr lang="en-US" dirty="0"/>
-              <a:t>Integration tests</a:t>
-            </a:r>
-          </a:p>
-        </p:txBody>
-      </p:sp>
-      <p:sp>
-        <p:nvSpPr>
-          <p:cNvPr id="4" name="Date Placeholder 3">
-            <a:extLst>
-              <a:ext uri="{FF2B5EF4-FFF2-40B4-BE49-F238E27FC236}">
-                <a16:creationId xmlns:a16="http://schemas.microsoft.com/office/drawing/2014/main" id="{422F2481-E1BF-0673-AADD-550026A89217}"/>
+            <a:fld id="{AD622D1A-DF83-41A8-85FF-04D90BF831D3}" type="datetime3">
+              <a:rPr lang="en-US" smtClean="0"/>
+              <a:t>18 June 2026</a:t>
+            </a:fld>
+            <a:endParaRPr lang="en-US"/>
+          </a:p>
+        </p:txBody>
+      </p:sp>
+      <p:sp>
+        <p:nvSpPr>
+          <p:cNvPr id="5" name="Slide Number Placeholder 4">
+            <a:extLst>
+              <a:ext uri="{FF2B5EF4-FFF2-40B4-BE49-F238E27FC236}">
+                <a16:creationId xmlns:a16="http://schemas.microsoft.com/office/drawing/2014/main" id="{1D5C8B6B-CA8E-CB24-2673-8ADE45EA2568}"/>
               </a:ext>
             </a:extLst>
           </p:cNvPr>
@@ -28712,7 +29066,7 @@
             <a:spLocks noGrp="1"/>
           </p:cNvSpPr>
           <p:nvPr>
-            <p:ph type="dt" sz="half" idx="10"/>
+            <p:ph type="sldNum" sz="quarter" idx="11"/>
           </p:nvPr>
         </p:nvSpPr>
         <p:spPr/>
@@ -28720,52 +29074,51 @@
           <a:bodyPr/>
           <a:lstStyle/>
           <a:p>
-            <a:endParaRPr lang="en-US"/>
-          </a:p>
-        </p:txBody>
-      </p:sp>
-      <p:sp>
-        <p:nvSpPr>
-          <p:cNvPr id="6" name="Slide Number Placeholder 5">
-            <a:extLst>
-              <a:ext uri="{FF2B5EF4-FFF2-40B4-BE49-F238E27FC236}">
-                <a16:creationId xmlns:a16="http://schemas.microsoft.com/office/drawing/2014/main" id="{7C2A292B-1E3A-EB90-3705-C1841930EC51}"/>
-              </a:ext>
-            </a:extLst>
-          </p:cNvPr>
-          <p:cNvSpPr>
-            <a:spLocks noGrp="1"/>
-          </p:cNvSpPr>
-          <p:nvPr>
-            <p:ph type="sldNum" sz="quarter" idx="11"/>
-          </p:nvPr>
-        </p:nvSpPr>
-        <p:spPr/>
-        <p:txBody>
-          <a:bodyPr/>
-          <a:lstStyle/>
-          <a:p>
-            <a:pPr marL="0" lvl="0" indent="0" algn="r" rtl="0">
-              <a:spcBef>
-                <a:spcPts val="0"/>
-              </a:spcBef>
-              <a:spcAft>
-                <a:spcPts val="0"/>
-              </a:spcAft>
-              <a:buNone/>
-            </a:pPr>
-            <a:fld id="{00000000-1234-1234-1234-123412341234}" type="slidenum">
-              <a:rPr lang="en" smtClean="0"/>
+            <a:fld id="{64E5BE4B-2FBF-4174-9E62-85FAD1CB43A6}" type="slidenum">
+              <a:rPr lang="en-US" smtClean="0"/>
+              <a:pPr/>
               <a:t>21</a:t>
             </a:fld>
-            <a:endParaRPr lang="en"/>
-          </a:p>
-        </p:txBody>
-      </p:sp>
+            <a:endParaRPr lang="en-US"/>
+          </a:p>
+        </p:txBody>
+      </p:sp>
+      <p:pic>
+        <p:nvPicPr>
+          <p:cNvPr id="11" name="Content Placeholder 10">
+            <a:extLst>
+              <a:ext uri="{FF2B5EF4-FFF2-40B4-BE49-F238E27FC236}">
+                <a16:creationId xmlns:a16="http://schemas.microsoft.com/office/drawing/2014/main" id="{A7D20357-922E-650B-37D3-399955890E5B}"/>
+              </a:ext>
+            </a:extLst>
+          </p:cNvPr>
+          <p:cNvPicPr>
+            <a:picLocks noGrp="1" noChangeAspect="1"/>
+          </p:cNvPicPr>
+          <p:nvPr>
+            <p:ph idx="1"/>
+          </p:nvPr>
+        </p:nvPicPr>
+        <p:blipFill>
+          <a:blip r:embed="rId3"/>
+          <a:stretch>
+            <a:fillRect/>
+          </a:stretch>
+        </p:blipFill>
+        <p:spPr>
+          <a:xfrm>
+            <a:off x="3995520" y="171559"/>
+            <a:ext cx="4991441" cy="4800382"/>
+          </a:xfrm>
+          <a:prstGeom prst="rect">
+            <a:avLst/>
+          </a:prstGeom>
+        </p:spPr>
+      </p:pic>
     </p:spTree>
     <p:extLst>
       <p:ext uri="{BB962C8B-B14F-4D97-AF65-F5344CB8AC3E}">
-        <p14:creationId xmlns:p14="http://schemas.microsoft.com/office/powerpoint/2010/main" val="4085729229"/>
+        <p14:creationId xmlns:p14="http://schemas.microsoft.com/office/powerpoint/2010/main" val="649209541"/>
       </p:ext>
     </p:extLst>
   </p:cSld>
@@ -28794,6 +29147,2283 @@
       </p:grpSpPr>
       <p:sp>
         <p:nvSpPr>
+          <p:cNvPr id="2" name="Title 1">
+            <a:extLst>
+              <a:ext uri="{FF2B5EF4-FFF2-40B4-BE49-F238E27FC236}">
+                <a16:creationId xmlns:a16="http://schemas.microsoft.com/office/drawing/2014/main" id="{1E90BFE8-BEA7-3940-667B-3FF6A7BCDE23}"/>
+              </a:ext>
+            </a:extLst>
+          </p:cNvPr>
+          <p:cNvSpPr>
+            <a:spLocks noGrp="1"/>
+          </p:cNvSpPr>
+          <p:nvPr>
+            <p:ph type="title"/>
+          </p:nvPr>
+        </p:nvSpPr>
+        <p:spPr/>
+        <p:txBody>
+          <a:bodyPr/>
+          <a:lstStyle/>
+          <a:p>
+            <a:r>
+              <a:rPr lang="en-US" dirty="0"/>
+              <a:t>Mocking </a:t>
+            </a:r>
+            <a:r>
+              <a:rPr lang="en-US"/>
+              <a:t>External References</a:t>
+            </a:r>
+            <a:endParaRPr lang="en-US" dirty="0"/>
+          </a:p>
+        </p:txBody>
+      </p:sp>
+      <p:sp>
+        <p:nvSpPr>
+          <p:cNvPr id="4" name="Date Placeholder 3">
+            <a:extLst>
+              <a:ext uri="{FF2B5EF4-FFF2-40B4-BE49-F238E27FC236}">
+                <a16:creationId xmlns:a16="http://schemas.microsoft.com/office/drawing/2014/main" id="{4FFB9305-2CBA-FCFF-86FC-1A2D6F2DCA86}"/>
+              </a:ext>
+            </a:extLst>
+          </p:cNvPr>
+          <p:cNvSpPr>
+            <a:spLocks noGrp="1"/>
+          </p:cNvSpPr>
+          <p:nvPr>
+            <p:ph type="dt" sz="half" idx="10"/>
+          </p:nvPr>
+        </p:nvSpPr>
+        <p:spPr/>
+        <p:txBody>
+          <a:bodyPr/>
+          <a:lstStyle/>
+          <a:p>
+            <a:fld id="{AD622D1A-DF83-41A8-85FF-04D90BF831D3}" type="datetime3">
+              <a:rPr lang="en-US" smtClean="0"/>
+              <a:t>18 June 2026</a:t>
+            </a:fld>
+            <a:endParaRPr lang="en-US"/>
+          </a:p>
+        </p:txBody>
+      </p:sp>
+      <p:sp>
+        <p:nvSpPr>
+          <p:cNvPr id="5" name="Slide Number Placeholder 4">
+            <a:extLst>
+              <a:ext uri="{FF2B5EF4-FFF2-40B4-BE49-F238E27FC236}">
+                <a16:creationId xmlns:a16="http://schemas.microsoft.com/office/drawing/2014/main" id="{BC24ECD0-6721-C76E-C7B4-37CC4871FADC}"/>
+              </a:ext>
+            </a:extLst>
+          </p:cNvPr>
+          <p:cNvSpPr>
+            <a:spLocks noGrp="1"/>
+          </p:cNvSpPr>
+          <p:nvPr>
+            <p:ph type="sldNum" sz="quarter" idx="11"/>
+          </p:nvPr>
+        </p:nvSpPr>
+        <p:spPr/>
+        <p:txBody>
+          <a:bodyPr/>
+          <a:lstStyle/>
+          <a:p>
+            <a:fld id="{64E5BE4B-2FBF-4174-9E62-85FAD1CB43A6}" type="slidenum">
+              <a:rPr lang="en-US" smtClean="0"/>
+              <a:pPr/>
+              <a:t>22</a:t>
+            </a:fld>
+            <a:endParaRPr lang="en-US"/>
+          </a:p>
+        </p:txBody>
+      </p:sp>
+      <p:sp>
+        <p:nvSpPr>
+          <p:cNvPr id="9" name="TextBox 8">
+            <a:extLst>
+              <a:ext uri="{FF2B5EF4-FFF2-40B4-BE49-F238E27FC236}">
+                <a16:creationId xmlns:a16="http://schemas.microsoft.com/office/drawing/2014/main" id="{0A99213A-75CF-F98A-E60B-E51AD918363A}"/>
+              </a:ext>
+            </a:extLst>
+          </p:cNvPr>
+          <p:cNvSpPr txBox="1"/>
+          <p:nvPr/>
+        </p:nvSpPr>
+        <p:spPr>
+          <a:xfrm>
+            <a:off x="719732" y="1336317"/>
+            <a:ext cx="7704536" cy="2248051"/>
+          </a:xfrm>
+          <a:prstGeom prst="rect">
+            <a:avLst/>
+          </a:prstGeom>
+          <a:noFill/>
+        </p:spPr>
+        <p:txBody>
+          <a:bodyPr wrap="square">
+            <a:spAutoFit/>
+          </a:bodyPr>
+          <a:lstStyle/>
+          <a:p>
+            <a:pPr>
+              <a:lnSpc>
+                <a:spcPts val="1425"/>
+              </a:lnSpc>
+              <a:buNone/>
+            </a:pPr>
+            <a:r>
+              <a:rPr lang="en-US" b="0" dirty="0">
+                <a:solidFill>
+                  <a:srgbClr val="AF00DB"/>
+                </a:solidFill>
+                <a:effectLst/>
+                <a:latin typeface="Consolas" panose="020B0609020204030204" pitchFamily="49" charset="0"/>
+              </a:rPr>
+              <a:t>import</a:t>
+            </a:r>
+            <a:r>
+              <a:rPr lang="en-US" b="0" dirty="0">
+                <a:solidFill>
+                  <a:srgbClr val="000000"/>
+                </a:solidFill>
+                <a:effectLst/>
+                <a:latin typeface="Consolas" panose="020B0609020204030204" pitchFamily="49" charset="0"/>
+              </a:rPr>
+              <a:t> </a:t>
+            </a:r>
+            <a:r>
+              <a:rPr lang="en-US" b="0" dirty="0">
+                <a:solidFill>
+                  <a:srgbClr val="267F99"/>
+                </a:solidFill>
+                <a:effectLst/>
+                <a:latin typeface="Consolas" panose="020B0609020204030204" pitchFamily="49" charset="0"/>
+              </a:rPr>
+              <a:t>requests</a:t>
+            </a:r>
+            <a:endParaRPr lang="en-US" b="0" dirty="0">
+              <a:solidFill>
+                <a:srgbClr val="000000"/>
+              </a:solidFill>
+              <a:effectLst/>
+              <a:latin typeface="Consolas" panose="020B0609020204030204" pitchFamily="49" charset="0"/>
+            </a:endParaRPr>
+          </a:p>
+          <a:p>
+            <a:pPr>
+              <a:lnSpc>
+                <a:spcPts val="1425"/>
+              </a:lnSpc>
+              <a:buNone/>
+            </a:pPr>
+            <a:br>
+              <a:rPr lang="en-US" b="0" dirty="0">
+                <a:solidFill>
+                  <a:srgbClr val="000000"/>
+                </a:solidFill>
+                <a:effectLst/>
+                <a:latin typeface="Consolas" panose="020B0609020204030204" pitchFamily="49" charset="0"/>
+              </a:rPr>
+            </a:br>
+            <a:br>
+              <a:rPr lang="en-US" b="0" dirty="0">
+                <a:solidFill>
+                  <a:srgbClr val="000000"/>
+                </a:solidFill>
+                <a:effectLst/>
+                <a:latin typeface="Consolas" panose="020B0609020204030204" pitchFamily="49" charset="0"/>
+              </a:rPr>
+            </a:br>
+            <a:endParaRPr lang="en-US" b="0" dirty="0">
+              <a:solidFill>
+                <a:srgbClr val="000000"/>
+              </a:solidFill>
+              <a:effectLst/>
+              <a:latin typeface="Consolas" panose="020B0609020204030204" pitchFamily="49" charset="0"/>
+            </a:endParaRPr>
+          </a:p>
+          <a:p>
+            <a:pPr>
+              <a:lnSpc>
+                <a:spcPts val="1425"/>
+              </a:lnSpc>
+              <a:buNone/>
+            </a:pPr>
+            <a:r>
+              <a:rPr lang="en-US" b="0" dirty="0">
+                <a:solidFill>
+                  <a:srgbClr val="0000FF"/>
+                </a:solidFill>
+                <a:effectLst/>
+                <a:latin typeface="Consolas" panose="020B0609020204030204" pitchFamily="49" charset="0"/>
+              </a:rPr>
+              <a:t>def</a:t>
+            </a:r>
+            <a:r>
+              <a:rPr lang="en-US" b="0" dirty="0">
+                <a:solidFill>
+                  <a:srgbClr val="000000"/>
+                </a:solidFill>
+                <a:effectLst/>
+                <a:latin typeface="Consolas" panose="020B0609020204030204" pitchFamily="49" charset="0"/>
+              </a:rPr>
+              <a:t> </a:t>
+            </a:r>
+            <a:r>
+              <a:rPr lang="en-US" b="0" dirty="0" err="1">
+                <a:solidFill>
+                  <a:srgbClr val="795E26"/>
+                </a:solidFill>
+                <a:effectLst/>
+                <a:latin typeface="Consolas" panose="020B0609020204030204" pitchFamily="49" charset="0"/>
+              </a:rPr>
+              <a:t>get_user_name</a:t>
+            </a:r>
+            <a:r>
+              <a:rPr lang="en-US" b="0" dirty="0">
+                <a:solidFill>
+                  <a:srgbClr val="000000"/>
+                </a:solidFill>
+                <a:effectLst/>
+                <a:latin typeface="Consolas" panose="020B0609020204030204" pitchFamily="49" charset="0"/>
+              </a:rPr>
+              <a:t>(</a:t>
+            </a:r>
+            <a:r>
+              <a:rPr lang="en-US" b="0" dirty="0" err="1">
+                <a:solidFill>
+                  <a:srgbClr val="001080"/>
+                </a:solidFill>
+                <a:effectLst/>
+                <a:latin typeface="Consolas" panose="020B0609020204030204" pitchFamily="49" charset="0"/>
+              </a:rPr>
+              <a:t>user_id</a:t>
+            </a:r>
+            <a:r>
+              <a:rPr lang="en-US" b="0" dirty="0">
+                <a:solidFill>
+                  <a:srgbClr val="000000"/>
+                </a:solidFill>
+                <a:effectLst/>
+                <a:latin typeface="Consolas" panose="020B0609020204030204" pitchFamily="49" charset="0"/>
+              </a:rPr>
+              <a:t>):</a:t>
+            </a:r>
+          </a:p>
+          <a:p>
+            <a:pPr>
+              <a:lnSpc>
+                <a:spcPts val="1425"/>
+              </a:lnSpc>
+              <a:buNone/>
+            </a:pPr>
+            <a:r>
+              <a:rPr lang="en-US" b="0" dirty="0">
+                <a:solidFill>
+                  <a:srgbClr val="000000"/>
+                </a:solidFill>
+                <a:effectLst/>
+                <a:latin typeface="Consolas" panose="020B0609020204030204" pitchFamily="49" charset="0"/>
+              </a:rPr>
+              <a:t>    </a:t>
+            </a:r>
+            <a:r>
+              <a:rPr lang="en-US" b="0" dirty="0">
+                <a:solidFill>
+                  <a:srgbClr val="A31515"/>
+                </a:solidFill>
+                <a:effectLst/>
+                <a:latin typeface="Consolas" panose="020B0609020204030204" pitchFamily="49" charset="0"/>
+              </a:rPr>
+              <a:t>"""Fetch a user's name from an API."""</a:t>
+            </a:r>
+            <a:endParaRPr lang="en-US" b="0" dirty="0">
+              <a:solidFill>
+                <a:srgbClr val="000000"/>
+              </a:solidFill>
+              <a:effectLst/>
+              <a:latin typeface="Consolas" panose="020B0609020204030204" pitchFamily="49" charset="0"/>
+            </a:endParaRPr>
+          </a:p>
+          <a:p>
+            <a:pPr>
+              <a:lnSpc>
+                <a:spcPts val="1425"/>
+              </a:lnSpc>
+              <a:buNone/>
+            </a:pPr>
+            <a:r>
+              <a:rPr lang="en-US" b="0" dirty="0">
+                <a:solidFill>
+                  <a:srgbClr val="000000"/>
+                </a:solidFill>
+                <a:effectLst/>
+                <a:latin typeface="Consolas" panose="020B0609020204030204" pitchFamily="49" charset="0"/>
+              </a:rPr>
+              <a:t>    </a:t>
+            </a:r>
+            <a:r>
+              <a:rPr lang="en-US" b="0" dirty="0">
+                <a:solidFill>
+                  <a:srgbClr val="001080"/>
+                </a:solidFill>
+                <a:effectLst/>
+                <a:latin typeface="Consolas" panose="020B0609020204030204" pitchFamily="49" charset="0"/>
+              </a:rPr>
+              <a:t>response</a:t>
+            </a:r>
+            <a:r>
+              <a:rPr lang="en-US" b="0" dirty="0">
+                <a:solidFill>
+                  <a:srgbClr val="000000"/>
+                </a:solidFill>
+                <a:effectLst/>
+                <a:latin typeface="Consolas" panose="020B0609020204030204" pitchFamily="49" charset="0"/>
+              </a:rPr>
+              <a:t> = </a:t>
+            </a:r>
+            <a:r>
+              <a:rPr lang="en-US" b="0" dirty="0" err="1">
+                <a:solidFill>
+                  <a:srgbClr val="267F99"/>
+                </a:solidFill>
+                <a:effectLst/>
+                <a:latin typeface="Consolas" panose="020B0609020204030204" pitchFamily="49" charset="0"/>
+              </a:rPr>
+              <a:t>requests</a:t>
+            </a:r>
+            <a:r>
+              <a:rPr lang="en-US" b="0" dirty="0" err="1">
+                <a:solidFill>
+                  <a:srgbClr val="000000"/>
+                </a:solidFill>
+                <a:effectLst/>
+                <a:latin typeface="Consolas" panose="020B0609020204030204" pitchFamily="49" charset="0"/>
+              </a:rPr>
+              <a:t>.</a:t>
+            </a:r>
+            <a:r>
+              <a:rPr lang="en-US" b="0" dirty="0" err="1">
+                <a:solidFill>
+                  <a:srgbClr val="795E26"/>
+                </a:solidFill>
+                <a:effectLst/>
+                <a:latin typeface="Consolas" panose="020B0609020204030204" pitchFamily="49" charset="0"/>
+              </a:rPr>
+              <a:t>get</a:t>
+            </a:r>
+            <a:r>
+              <a:rPr lang="en-US" b="0" dirty="0">
+                <a:solidFill>
+                  <a:srgbClr val="000000"/>
+                </a:solidFill>
+                <a:effectLst/>
+                <a:latin typeface="Consolas" panose="020B0609020204030204" pitchFamily="49" charset="0"/>
+              </a:rPr>
+              <a:t>(</a:t>
+            </a:r>
+            <a:r>
+              <a:rPr lang="en-US" b="0" dirty="0" err="1">
+                <a:solidFill>
+                  <a:srgbClr val="0000FF"/>
+                </a:solidFill>
+                <a:effectLst/>
+                <a:latin typeface="Consolas" panose="020B0609020204030204" pitchFamily="49" charset="0"/>
+              </a:rPr>
+              <a:t>f</a:t>
+            </a:r>
+            <a:r>
+              <a:rPr lang="en-US" b="0" dirty="0" err="1">
+                <a:solidFill>
+                  <a:srgbClr val="A31515"/>
+                </a:solidFill>
+                <a:effectLst/>
+                <a:latin typeface="Consolas" panose="020B0609020204030204" pitchFamily="49" charset="0"/>
+              </a:rPr>
+              <a:t>"https</a:t>
+            </a:r>
+            <a:r>
+              <a:rPr lang="en-US" b="0" dirty="0">
+                <a:solidFill>
+                  <a:srgbClr val="A31515"/>
+                </a:solidFill>
+                <a:effectLst/>
+                <a:latin typeface="Consolas" panose="020B0609020204030204" pitchFamily="49" charset="0"/>
+              </a:rPr>
+              <a:t>://api.example.com/users/</a:t>
+            </a:r>
+            <a:r>
+              <a:rPr lang="en-US" b="0" dirty="0">
+                <a:solidFill>
+                  <a:srgbClr val="0000FF"/>
+                </a:solidFill>
+                <a:effectLst/>
+                <a:latin typeface="Consolas" panose="020B0609020204030204" pitchFamily="49" charset="0"/>
+              </a:rPr>
+              <a:t>{</a:t>
+            </a:r>
+            <a:r>
+              <a:rPr lang="en-US" b="0" dirty="0" err="1">
+                <a:solidFill>
+                  <a:srgbClr val="001080"/>
+                </a:solidFill>
+                <a:effectLst/>
+                <a:latin typeface="Consolas" panose="020B0609020204030204" pitchFamily="49" charset="0"/>
+              </a:rPr>
+              <a:t>user_id</a:t>
+            </a:r>
+            <a:r>
+              <a:rPr lang="en-US" b="0" dirty="0">
+                <a:solidFill>
+                  <a:srgbClr val="0000FF"/>
+                </a:solidFill>
+                <a:effectLst/>
+                <a:latin typeface="Consolas" panose="020B0609020204030204" pitchFamily="49" charset="0"/>
+              </a:rPr>
+              <a:t>}</a:t>
+            </a:r>
+            <a:r>
+              <a:rPr lang="en-US" b="0" dirty="0">
+                <a:solidFill>
+                  <a:srgbClr val="A31515"/>
+                </a:solidFill>
+                <a:effectLst/>
+                <a:latin typeface="Consolas" panose="020B0609020204030204" pitchFamily="49" charset="0"/>
+              </a:rPr>
+              <a:t>"</a:t>
+            </a:r>
+            <a:r>
+              <a:rPr lang="en-US" b="0" dirty="0">
+                <a:solidFill>
+                  <a:srgbClr val="000000"/>
+                </a:solidFill>
+                <a:effectLst/>
+                <a:latin typeface="Consolas" panose="020B0609020204030204" pitchFamily="49" charset="0"/>
+              </a:rPr>
+              <a:t>)</a:t>
+            </a:r>
+          </a:p>
+          <a:p>
+            <a:pPr>
+              <a:lnSpc>
+                <a:spcPts val="1425"/>
+              </a:lnSpc>
+              <a:buNone/>
+            </a:pPr>
+            <a:r>
+              <a:rPr lang="en-US" b="0" dirty="0">
+                <a:solidFill>
+                  <a:srgbClr val="000000"/>
+                </a:solidFill>
+                <a:effectLst/>
+                <a:latin typeface="Consolas" panose="020B0609020204030204" pitchFamily="49" charset="0"/>
+              </a:rPr>
+              <a:t>    </a:t>
+            </a:r>
+            <a:r>
+              <a:rPr lang="en-US" b="0" dirty="0">
+                <a:solidFill>
+                  <a:srgbClr val="AF00DB"/>
+                </a:solidFill>
+                <a:effectLst/>
+                <a:latin typeface="Consolas" panose="020B0609020204030204" pitchFamily="49" charset="0"/>
+              </a:rPr>
+              <a:t>if</a:t>
+            </a:r>
+            <a:r>
+              <a:rPr lang="en-US" b="0" dirty="0">
+                <a:solidFill>
+                  <a:srgbClr val="000000"/>
+                </a:solidFill>
+                <a:effectLst/>
+                <a:latin typeface="Consolas" panose="020B0609020204030204" pitchFamily="49" charset="0"/>
+              </a:rPr>
+              <a:t> </a:t>
+            </a:r>
+            <a:r>
+              <a:rPr lang="en-US" b="0" dirty="0" err="1">
+                <a:solidFill>
+                  <a:srgbClr val="001080"/>
+                </a:solidFill>
+                <a:effectLst/>
+                <a:latin typeface="Consolas" panose="020B0609020204030204" pitchFamily="49" charset="0"/>
+              </a:rPr>
+              <a:t>response</a:t>
+            </a:r>
+            <a:r>
+              <a:rPr lang="en-US" b="0" dirty="0" err="1">
+                <a:solidFill>
+                  <a:srgbClr val="000000"/>
+                </a:solidFill>
+                <a:effectLst/>
+                <a:latin typeface="Consolas" panose="020B0609020204030204" pitchFamily="49" charset="0"/>
+              </a:rPr>
+              <a:t>.</a:t>
+            </a:r>
+            <a:r>
+              <a:rPr lang="en-US" b="0" dirty="0" err="1">
+                <a:solidFill>
+                  <a:srgbClr val="001080"/>
+                </a:solidFill>
+                <a:effectLst/>
+                <a:latin typeface="Consolas" panose="020B0609020204030204" pitchFamily="49" charset="0"/>
+              </a:rPr>
+              <a:t>status_code</a:t>
+            </a:r>
+            <a:r>
+              <a:rPr lang="en-US" b="0" dirty="0">
+                <a:solidFill>
+                  <a:srgbClr val="000000"/>
+                </a:solidFill>
+                <a:effectLst/>
+                <a:latin typeface="Consolas" panose="020B0609020204030204" pitchFamily="49" charset="0"/>
+              </a:rPr>
+              <a:t> == </a:t>
+            </a:r>
+            <a:r>
+              <a:rPr lang="en-US" b="0" dirty="0">
+                <a:solidFill>
+                  <a:srgbClr val="098658"/>
+                </a:solidFill>
+                <a:effectLst/>
+                <a:latin typeface="Consolas" panose="020B0609020204030204" pitchFamily="49" charset="0"/>
+              </a:rPr>
+              <a:t>200</a:t>
+            </a:r>
+            <a:r>
+              <a:rPr lang="en-US" b="0" dirty="0">
+                <a:solidFill>
+                  <a:srgbClr val="000000"/>
+                </a:solidFill>
+                <a:effectLst/>
+                <a:latin typeface="Consolas" panose="020B0609020204030204" pitchFamily="49" charset="0"/>
+              </a:rPr>
+              <a:t>:</a:t>
+            </a:r>
+          </a:p>
+          <a:p>
+            <a:pPr>
+              <a:lnSpc>
+                <a:spcPts val="1425"/>
+              </a:lnSpc>
+              <a:buNone/>
+            </a:pPr>
+            <a:r>
+              <a:rPr lang="en-US" b="0" dirty="0">
+                <a:solidFill>
+                  <a:srgbClr val="000000"/>
+                </a:solidFill>
+                <a:effectLst/>
+                <a:latin typeface="Consolas" panose="020B0609020204030204" pitchFamily="49" charset="0"/>
+              </a:rPr>
+              <a:t>        </a:t>
+            </a:r>
+            <a:r>
+              <a:rPr lang="en-US" b="0" dirty="0">
+                <a:solidFill>
+                  <a:srgbClr val="AF00DB"/>
+                </a:solidFill>
+                <a:effectLst/>
+                <a:latin typeface="Consolas" panose="020B0609020204030204" pitchFamily="49" charset="0"/>
+              </a:rPr>
+              <a:t>return</a:t>
+            </a:r>
+            <a:r>
+              <a:rPr lang="en-US" b="0" dirty="0">
+                <a:solidFill>
+                  <a:srgbClr val="000000"/>
+                </a:solidFill>
+                <a:effectLst/>
+                <a:latin typeface="Consolas" panose="020B0609020204030204" pitchFamily="49" charset="0"/>
+              </a:rPr>
+              <a:t> </a:t>
+            </a:r>
+            <a:r>
+              <a:rPr lang="en-US" b="0" dirty="0" err="1">
+                <a:solidFill>
+                  <a:srgbClr val="001080"/>
+                </a:solidFill>
+                <a:effectLst/>
+                <a:latin typeface="Consolas" panose="020B0609020204030204" pitchFamily="49" charset="0"/>
+              </a:rPr>
+              <a:t>response</a:t>
+            </a:r>
+            <a:r>
+              <a:rPr lang="en-US" b="0" dirty="0" err="1">
+                <a:solidFill>
+                  <a:srgbClr val="000000"/>
+                </a:solidFill>
+                <a:effectLst/>
+                <a:latin typeface="Consolas" panose="020B0609020204030204" pitchFamily="49" charset="0"/>
+              </a:rPr>
+              <a:t>.</a:t>
+            </a:r>
+            <a:r>
+              <a:rPr lang="en-US" b="0" dirty="0" err="1">
+                <a:solidFill>
+                  <a:srgbClr val="795E26"/>
+                </a:solidFill>
+                <a:effectLst/>
+                <a:latin typeface="Consolas" panose="020B0609020204030204" pitchFamily="49" charset="0"/>
+              </a:rPr>
+              <a:t>json</a:t>
+            </a:r>
+            <a:r>
+              <a:rPr lang="en-US" b="0" dirty="0">
+                <a:solidFill>
+                  <a:srgbClr val="000000"/>
+                </a:solidFill>
+                <a:effectLst/>
+                <a:latin typeface="Consolas" panose="020B0609020204030204" pitchFamily="49" charset="0"/>
+              </a:rPr>
+              <a:t>().get(</a:t>
+            </a:r>
+            <a:r>
+              <a:rPr lang="en-US" b="0" dirty="0">
+                <a:solidFill>
+                  <a:srgbClr val="A31515"/>
+                </a:solidFill>
+                <a:effectLst/>
+                <a:latin typeface="Consolas" panose="020B0609020204030204" pitchFamily="49" charset="0"/>
+              </a:rPr>
+              <a:t>"name"</a:t>
+            </a:r>
+            <a:r>
+              <a:rPr lang="en-US" b="0" dirty="0">
+                <a:solidFill>
+                  <a:srgbClr val="000000"/>
+                </a:solidFill>
+                <a:effectLst/>
+                <a:latin typeface="Consolas" panose="020B0609020204030204" pitchFamily="49" charset="0"/>
+              </a:rPr>
+              <a:t>)</a:t>
+            </a:r>
+          </a:p>
+          <a:p>
+            <a:pPr>
+              <a:lnSpc>
+                <a:spcPts val="1425"/>
+              </a:lnSpc>
+              <a:buNone/>
+            </a:pPr>
+            <a:r>
+              <a:rPr lang="en-US" b="0" dirty="0">
+                <a:solidFill>
+                  <a:srgbClr val="000000"/>
+                </a:solidFill>
+                <a:effectLst/>
+                <a:latin typeface="Consolas" panose="020B0609020204030204" pitchFamily="49" charset="0"/>
+              </a:rPr>
+              <a:t>    </a:t>
+            </a:r>
+            <a:r>
+              <a:rPr lang="en-US" b="0" dirty="0">
+                <a:solidFill>
+                  <a:srgbClr val="AF00DB"/>
+                </a:solidFill>
+                <a:effectLst/>
+                <a:latin typeface="Consolas" panose="020B0609020204030204" pitchFamily="49" charset="0"/>
+              </a:rPr>
+              <a:t>return</a:t>
+            </a:r>
+            <a:r>
+              <a:rPr lang="en-US" b="0" dirty="0">
+                <a:solidFill>
+                  <a:srgbClr val="000000"/>
+                </a:solidFill>
+                <a:effectLst/>
+                <a:latin typeface="Consolas" panose="020B0609020204030204" pitchFamily="49" charset="0"/>
+              </a:rPr>
+              <a:t> </a:t>
+            </a:r>
+            <a:r>
+              <a:rPr lang="en-US" b="0" dirty="0">
+                <a:solidFill>
+                  <a:srgbClr val="0000FF"/>
+                </a:solidFill>
+                <a:effectLst/>
+                <a:latin typeface="Consolas" panose="020B0609020204030204" pitchFamily="49" charset="0"/>
+              </a:rPr>
+              <a:t>None</a:t>
+            </a:r>
+            <a:endParaRPr lang="en-US" b="0" dirty="0">
+              <a:solidFill>
+                <a:srgbClr val="000000"/>
+              </a:solidFill>
+              <a:effectLst/>
+              <a:latin typeface="Consolas" panose="020B0609020204030204" pitchFamily="49" charset="0"/>
+            </a:endParaRPr>
+          </a:p>
+          <a:p>
+            <a:pPr>
+              <a:lnSpc>
+                <a:spcPts val="1425"/>
+              </a:lnSpc>
+              <a:buNone/>
+            </a:pPr>
+            <a:br>
+              <a:rPr lang="en-US" b="0" dirty="0">
+                <a:solidFill>
+                  <a:srgbClr val="000000"/>
+                </a:solidFill>
+                <a:effectLst/>
+                <a:latin typeface="Consolas" panose="020B0609020204030204" pitchFamily="49" charset="0"/>
+              </a:rPr>
+            </a:br>
+            <a:endParaRPr lang="en-US" b="0" dirty="0">
+              <a:solidFill>
+                <a:srgbClr val="000000"/>
+              </a:solidFill>
+              <a:effectLst/>
+              <a:latin typeface="Consolas" panose="020B0609020204030204" pitchFamily="49" charset="0"/>
+            </a:endParaRPr>
+          </a:p>
+        </p:txBody>
+      </p:sp>
+    </p:spTree>
+    <p:extLst>
+      <p:ext uri="{BB962C8B-B14F-4D97-AF65-F5344CB8AC3E}">
+        <p14:creationId xmlns:p14="http://schemas.microsoft.com/office/powerpoint/2010/main" val="1276382243"/>
+      </p:ext>
+    </p:extLst>
+  </p:cSld>
+  <p:clrMapOvr>
+    <a:masterClrMapping/>
+  </p:clrMapOvr>
+</p:sld>
+</file>
+
+<file path=ppt/slides/slide23.xml><?xml version="1.0" encoding="utf-8"?>
+<p:sld xmlns:a="http://schemas.openxmlformats.org/drawingml/2006/main" xmlns:r="http://schemas.openxmlformats.org/officeDocument/2006/relationships" xmlns:p="http://schemas.openxmlformats.org/presentationml/2006/main">
+  <p:cSld>
+    <p:spTree>
+      <p:nvGrpSpPr>
+        <p:cNvPr id="1" name="">
+          <a:extLst>
+            <a:ext uri="{FF2B5EF4-FFF2-40B4-BE49-F238E27FC236}">
+              <a16:creationId xmlns:a16="http://schemas.microsoft.com/office/drawing/2014/main" id="{A6CA065D-43EB-5C9E-6C77-5DE8A5399A20}"/>
+            </a:ext>
+          </a:extLst>
+        </p:cNvPr>
+        <p:cNvGrpSpPr/>
+        <p:nvPr/>
+      </p:nvGrpSpPr>
+      <p:grpSpPr>
+        <a:xfrm>
+          <a:off x="0" y="0"/>
+          <a:ext cx="0" cy="0"/>
+          <a:chOff x="0" y="0"/>
+          <a:chExt cx="0" cy="0"/>
+        </a:xfrm>
+      </p:grpSpPr>
+      <p:sp>
+        <p:nvSpPr>
+          <p:cNvPr id="2" name="Title 1">
+            <a:extLst>
+              <a:ext uri="{FF2B5EF4-FFF2-40B4-BE49-F238E27FC236}">
+                <a16:creationId xmlns:a16="http://schemas.microsoft.com/office/drawing/2014/main" id="{56143A9F-4B4E-95F8-EEB1-E8C38E2EE116}"/>
+              </a:ext>
+            </a:extLst>
+          </p:cNvPr>
+          <p:cNvSpPr>
+            <a:spLocks noGrp="1"/>
+          </p:cNvSpPr>
+          <p:nvPr>
+            <p:ph type="title"/>
+          </p:nvPr>
+        </p:nvSpPr>
+        <p:spPr>
+          <a:xfrm>
+            <a:off x="411480" y="336716"/>
+            <a:ext cx="6173470" cy="685800"/>
+          </a:xfrm>
+        </p:spPr>
+        <p:txBody>
+          <a:bodyPr/>
+          <a:lstStyle/>
+          <a:p>
+            <a:r>
+              <a:rPr lang="en-US" dirty="0"/>
+              <a:t>Mocking External References</a:t>
+            </a:r>
+          </a:p>
+        </p:txBody>
+      </p:sp>
+      <p:sp>
+        <p:nvSpPr>
+          <p:cNvPr id="4" name="Date Placeholder 3">
+            <a:extLst>
+              <a:ext uri="{FF2B5EF4-FFF2-40B4-BE49-F238E27FC236}">
+                <a16:creationId xmlns:a16="http://schemas.microsoft.com/office/drawing/2014/main" id="{A8D4005A-829B-83A4-FF01-9C589FCB36F9}"/>
+              </a:ext>
+            </a:extLst>
+          </p:cNvPr>
+          <p:cNvSpPr>
+            <a:spLocks noGrp="1"/>
+          </p:cNvSpPr>
+          <p:nvPr>
+            <p:ph type="dt" sz="half" idx="10"/>
+          </p:nvPr>
+        </p:nvSpPr>
+        <p:spPr/>
+        <p:txBody>
+          <a:bodyPr/>
+          <a:lstStyle/>
+          <a:p>
+            <a:fld id="{AD622D1A-DF83-41A8-85FF-04D90BF831D3}" type="datetime3">
+              <a:rPr lang="en-US" smtClean="0"/>
+              <a:t>18 June 2026</a:t>
+            </a:fld>
+            <a:endParaRPr lang="en-US"/>
+          </a:p>
+        </p:txBody>
+      </p:sp>
+      <p:sp>
+        <p:nvSpPr>
+          <p:cNvPr id="5" name="Slide Number Placeholder 4">
+            <a:extLst>
+              <a:ext uri="{FF2B5EF4-FFF2-40B4-BE49-F238E27FC236}">
+                <a16:creationId xmlns:a16="http://schemas.microsoft.com/office/drawing/2014/main" id="{018DB06A-57DF-70DE-DB16-44D75ADAB590}"/>
+              </a:ext>
+            </a:extLst>
+          </p:cNvPr>
+          <p:cNvSpPr>
+            <a:spLocks noGrp="1"/>
+          </p:cNvSpPr>
+          <p:nvPr>
+            <p:ph type="sldNum" sz="quarter" idx="11"/>
+          </p:nvPr>
+        </p:nvSpPr>
+        <p:spPr/>
+        <p:txBody>
+          <a:bodyPr/>
+          <a:lstStyle/>
+          <a:p>
+            <a:fld id="{64E5BE4B-2FBF-4174-9E62-85FAD1CB43A6}" type="slidenum">
+              <a:rPr lang="en-US" smtClean="0"/>
+              <a:pPr/>
+              <a:t>23</a:t>
+            </a:fld>
+            <a:endParaRPr lang="en-US"/>
+          </a:p>
+        </p:txBody>
+      </p:sp>
+      <p:sp>
+        <p:nvSpPr>
+          <p:cNvPr id="6" name="TextBox 5">
+            <a:extLst>
+              <a:ext uri="{FF2B5EF4-FFF2-40B4-BE49-F238E27FC236}">
+                <a16:creationId xmlns:a16="http://schemas.microsoft.com/office/drawing/2014/main" id="{5708AC6B-9053-105C-9BBA-D292A8B9CC69}"/>
+              </a:ext>
+            </a:extLst>
+          </p:cNvPr>
+          <p:cNvSpPr txBox="1"/>
+          <p:nvPr/>
+        </p:nvSpPr>
+        <p:spPr>
+          <a:xfrm>
+            <a:off x="720090" y="679616"/>
+            <a:ext cx="9867568" cy="4222951"/>
+          </a:xfrm>
+          <a:prstGeom prst="rect">
+            <a:avLst/>
+          </a:prstGeom>
+          <a:noFill/>
+        </p:spPr>
+        <p:txBody>
+          <a:bodyPr wrap="square">
+            <a:spAutoFit/>
+          </a:bodyPr>
+          <a:lstStyle/>
+          <a:p>
+            <a:pPr>
+              <a:lnSpc>
+                <a:spcPts val="1425"/>
+              </a:lnSpc>
+              <a:buNone/>
+            </a:pPr>
+            <a:r>
+              <a:rPr lang="en-US" b="0" dirty="0">
+                <a:solidFill>
+                  <a:srgbClr val="AF00DB"/>
+                </a:solidFill>
+                <a:effectLst/>
+                <a:latin typeface="Consolas" panose="020B0609020204030204" pitchFamily="49" charset="0"/>
+              </a:rPr>
+              <a:t>import</a:t>
+            </a:r>
+            <a:r>
+              <a:rPr lang="en-US" b="0" dirty="0">
+                <a:solidFill>
+                  <a:srgbClr val="000000"/>
+                </a:solidFill>
+                <a:effectLst/>
+                <a:latin typeface="Consolas" panose="020B0609020204030204" pitchFamily="49" charset="0"/>
+              </a:rPr>
+              <a:t> </a:t>
+            </a:r>
+            <a:r>
+              <a:rPr lang="en-US" b="0" dirty="0" err="1">
+                <a:solidFill>
+                  <a:srgbClr val="267F99"/>
+                </a:solidFill>
+                <a:effectLst/>
+                <a:latin typeface="Consolas" panose="020B0609020204030204" pitchFamily="49" charset="0"/>
+              </a:rPr>
+              <a:t>pytest</a:t>
+            </a:r>
+            <a:endParaRPr lang="en-US" b="0" dirty="0">
+              <a:solidFill>
+                <a:srgbClr val="000000"/>
+              </a:solidFill>
+              <a:effectLst/>
+              <a:latin typeface="Consolas" panose="020B0609020204030204" pitchFamily="49" charset="0"/>
+            </a:endParaRPr>
+          </a:p>
+          <a:p>
+            <a:pPr>
+              <a:lnSpc>
+                <a:spcPts val="1425"/>
+              </a:lnSpc>
+              <a:buNone/>
+            </a:pPr>
+            <a:r>
+              <a:rPr lang="en-US" b="0" dirty="0">
+                <a:solidFill>
+                  <a:srgbClr val="AF00DB"/>
+                </a:solidFill>
+                <a:effectLst/>
+                <a:latin typeface="Consolas" panose="020B0609020204030204" pitchFamily="49" charset="0"/>
+              </a:rPr>
+              <a:t>from</a:t>
+            </a:r>
+            <a:r>
+              <a:rPr lang="en-US" b="0" dirty="0">
+                <a:solidFill>
+                  <a:srgbClr val="000000"/>
+                </a:solidFill>
+                <a:effectLst/>
+                <a:latin typeface="Consolas" panose="020B0609020204030204" pitchFamily="49" charset="0"/>
+              </a:rPr>
+              <a:t> </a:t>
+            </a:r>
+            <a:r>
+              <a:rPr lang="en-US" b="0" dirty="0">
+                <a:solidFill>
+                  <a:srgbClr val="267F99"/>
+                </a:solidFill>
+                <a:effectLst/>
+                <a:latin typeface="Consolas" panose="020B0609020204030204" pitchFamily="49" charset="0"/>
+              </a:rPr>
+              <a:t>http</a:t>
+            </a:r>
+            <a:r>
+              <a:rPr lang="en-US" b="0" dirty="0">
+                <a:solidFill>
+                  <a:srgbClr val="000000"/>
+                </a:solidFill>
+                <a:effectLst/>
+                <a:latin typeface="Consolas" panose="020B0609020204030204" pitchFamily="49" charset="0"/>
+              </a:rPr>
+              <a:t> </a:t>
+            </a:r>
+            <a:r>
+              <a:rPr lang="en-US" b="0" dirty="0">
+                <a:solidFill>
+                  <a:srgbClr val="AF00DB"/>
+                </a:solidFill>
+                <a:effectLst/>
+                <a:latin typeface="Consolas" panose="020B0609020204030204" pitchFamily="49" charset="0"/>
+              </a:rPr>
+              <a:t>import</a:t>
+            </a:r>
+            <a:r>
+              <a:rPr lang="en-US" b="0" dirty="0">
+                <a:solidFill>
+                  <a:srgbClr val="000000"/>
+                </a:solidFill>
+                <a:effectLst/>
+                <a:latin typeface="Consolas" panose="020B0609020204030204" pitchFamily="49" charset="0"/>
+              </a:rPr>
+              <a:t> </a:t>
+            </a:r>
+            <a:r>
+              <a:rPr lang="en-US" b="0" dirty="0" err="1">
+                <a:solidFill>
+                  <a:srgbClr val="000000"/>
+                </a:solidFill>
+                <a:effectLst/>
+                <a:latin typeface="Consolas" panose="020B0609020204030204" pitchFamily="49" charset="0"/>
+              </a:rPr>
+              <a:t>get_user_name</a:t>
+            </a:r>
+            <a:endParaRPr lang="en-US" b="0" dirty="0">
+              <a:solidFill>
+                <a:srgbClr val="000000"/>
+              </a:solidFill>
+              <a:effectLst/>
+              <a:latin typeface="Consolas" panose="020B0609020204030204" pitchFamily="49" charset="0"/>
+            </a:endParaRPr>
+          </a:p>
+          <a:p>
+            <a:pPr>
+              <a:lnSpc>
+                <a:spcPts val="1425"/>
+              </a:lnSpc>
+              <a:buNone/>
+            </a:pPr>
+            <a:endParaRPr lang="en-US" b="0" dirty="0">
+              <a:solidFill>
+                <a:srgbClr val="000000"/>
+              </a:solidFill>
+              <a:effectLst/>
+              <a:latin typeface="Consolas" panose="020B0609020204030204" pitchFamily="49" charset="0"/>
+            </a:endParaRPr>
+          </a:p>
+          <a:p>
+            <a:pPr>
+              <a:lnSpc>
+                <a:spcPts val="1425"/>
+              </a:lnSpc>
+              <a:buNone/>
+            </a:pPr>
+            <a:r>
+              <a:rPr lang="en-US" b="0" dirty="0">
+                <a:solidFill>
+                  <a:srgbClr val="0000FF"/>
+                </a:solidFill>
+                <a:effectLst/>
+                <a:latin typeface="Consolas" panose="020B0609020204030204" pitchFamily="49" charset="0"/>
+              </a:rPr>
+              <a:t>def</a:t>
+            </a:r>
+            <a:r>
+              <a:rPr lang="en-US" b="0" dirty="0">
+                <a:solidFill>
+                  <a:srgbClr val="000000"/>
+                </a:solidFill>
+                <a:effectLst/>
+                <a:latin typeface="Consolas" panose="020B0609020204030204" pitchFamily="49" charset="0"/>
+              </a:rPr>
+              <a:t> </a:t>
+            </a:r>
+            <a:r>
+              <a:rPr lang="en-US" b="0" dirty="0" err="1">
+                <a:solidFill>
+                  <a:srgbClr val="795E26"/>
+                </a:solidFill>
+                <a:effectLst/>
+                <a:latin typeface="Consolas" panose="020B0609020204030204" pitchFamily="49" charset="0"/>
+              </a:rPr>
+              <a:t>test_get_user_name_success</a:t>
+            </a:r>
+            <a:r>
+              <a:rPr lang="en-US" b="0" dirty="0">
+                <a:solidFill>
+                  <a:srgbClr val="000000"/>
+                </a:solidFill>
+                <a:effectLst/>
+                <a:latin typeface="Consolas" panose="020B0609020204030204" pitchFamily="49" charset="0"/>
+              </a:rPr>
+              <a:t>(</a:t>
+            </a:r>
+            <a:r>
+              <a:rPr lang="en-US" b="0" dirty="0">
+                <a:solidFill>
+                  <a:srgbClr val="001080"/>
+                </a:solidFill>
+                <a:effectLst/>
+                <a:latin typeface="Consolas" panose="020B0609020204030204" pitchFamily="49" charset="0"/>
+              </a:rPr>
+              <a:t>mocker</a:t>
+            </a:r>
+            <a:r>
+              <a:rPr lang="en-US" b="0" dirty="0">
+                <a:solidFill>
+                  <a:srgbClr val="000000"/>
+                </a:solidFill>
+                <a:effectLst/>
+                <a:latin typeface="Consolas" panose="020B0609020204030204" pitchFamily="49" charset="0"/>
+              </a:rPr>
+              <a:t>):</a:t>
+            </a:r>
+          </a:p>
+          <a:p>
+            <a:pPr>
+              <a:lnSpc>
+                <a:spcPts val="1425"/>
+              </a:lnSpc>
+              <a:buNone/>
+            </a:pPr>
+            <a:r>
+              <a:rPr lang="en-US" b="0" dirty="0">
+                <a:solidFill>
+                  <a:srgbClr val="000000"/>
+                </a:solidFill>
+                <a:effectLst/>
+                <a:latin typeface="Consolas" panose="020B0609020204030204" pitchFamily="49" charset="0"/>
+              </a:rPr>
+              <a:t>    </a:t>
+            </a:r>
+            <a:r>
+              <a:rPr lang="en-US" b="0" dirty="0">
+                <a:solidFill>
+                  <a:srgbClr val="A31515"/>
+                </a:solidFill>
+                <a:effectLst/>
+                <a:latin typeface="Consolas" panose="020B0609020204030204" pitchFamily="49" charset="0"/>
+              </a:rPr>
+              <a:t>"""Test </a:t>
+            </a:r>
+            <a:r>
+              <a:rPr lang="en-US" b="0" dirty="0" err="1">
+                <a:solidFill>
+                  <a:srgbClr val="A31515"/>
+                </a:solidFill>
+                <a:effectLst/>
+                <a:latin typeface="Consolas" panose="020B0609020204030204" pitchFamily="49" charset="0"/>
+              </a:rPr>
+              <a:t>get_user_name</a:t>
+            </a:r>
+            <a:r>
+              <a:rPr lang="en-US" b="0" dirty="0">
+                <a:solidFill>
+                  <a:srgbClr val="A31515"/>
+                </a:solidFill>
+                <a:effectLst/>
+                <a:latin typeface="Consolas" panose="020B0609020204030204" pitchFamily="49" charset="0"/>
+              </a:rPr>
+              <a:t> with a mocked </a:t>
+            </a:r>
+            <a:r>
+              <a:rPr lang="en-US" b="0" dirty="0" err="1">
+                <a:solidFill>
+                  <a:srgbClr val="A31515"/>
+                </a:solidFill>
+                <a:effectLst/>
+                <a:latin typeface="Consolas" panose="020B0609020204030204" pitchFamily="49" charset="0"/>
+              </a:rPr>
+              <a:t>requests.get</a:t>
+            </a:r>
+            <a:r>
+              <a:rPr lang="en-US" b="0" dirty="0">
+                <a:solidFill>
+                  <a:srgbClr val="A31515"/>
+                </a:solidFill>
+                <a:effectLst/>
+                <a:latin typeface="Consolas" panose="020B0609020204030204" pitchFamily="49" charset="0"/>
+              </a:rPr>
+              <a:t>"""</a:t>
+            </a:r>
+            <a:br>
+              <a:rPr lang="en-US" b="0" dirty="0">
+                <a:solidFill>
+                  <a:srgbClr val="000000"/>
+                </a:solidFill>
+                <a:effectLst/>
+                <a:latin typeface="Consolas" panose="020B0609020204030204" pitchFamily="49" charset="0"/>
+              </a:rPr>
+            </a:br>
+            <a:endParaRPr lang="en-US" b="0" dirty="0">
+              <a:solidFill>
+                <a:srgbClr val="000000"/>
+              </a:solidFill>
+              <a:effectLst/>
+              <a:latin typeface="Consolas" panose="020B0609020204030204" pitchFamily="49" charset="0"/>
+            </a:endParaRPr>
+          </a:p>
+          <a:p>
+            <a:pPr>
+              <a:lnSpc>
+                <a:spcPts val="1425"/>
+              </a:lnSpc>
+              <a:buNone/>
+            </a:pPr>
+            <a:r>
+              <a:rPr lang="en-US" b="0" dirty="0">
+                <a:solidFill>
+                  <a:srgbClr val="000000"/>
+                </a:solidFill>
+                <a:effectLst/>
+                <a:latin typeface="Consolas" panose="020B0609020204030204" pitchFamily="49" charset="0"/>
+              </a:rPr>
+              <a:t>    </a:t>
+            </a:r>
+            <a:r>
+              <a:rPr lang="en-US" b="0" dirty="0">
+                <a:solidFill>
+                  <a:srgbClr val="008000"/>
+                </a:solidFill>
+                <a:effectLst/>
+                <a:latin typeface="Consolas" panose="020B0609020204030204" pitchFamily="49" charset="0"/>
+              </a:rPr>
+              <a:t># Create a mock response object</a:t>
+            </a:r>
+            <a:endParaRPr lang="en-US" b="0" dirty="0">
+              <a:solidFill>
+                <a:srgbClr val="000000"/>
+              </a:solidFill>
+              <a:effectLst/>
+              <a:latin typeface="Consolas" panose="020B0609020204030204" pitchFamily="49" charset="0"/>
+            </a:endParaRPr>
+          </a:p>
+          <a:p>
+            <a:pPr>
+              <a:lnSpc>
+                <a:spcPts val="1425"/>
+              </a:lnSpc>
+              <a:buNone/>
+            </a:pPr>
+            <a:r>
+              <a:rPr lang="en-US" b="0" dirty="0">
+                <a:solidFill>
+                  <a:srgbClr val="000000"/>
+                </a:solidFill>
+                <a:effectLst/>
+                <a:latin typeface="Consolas" panose="020B0609020204030204" pitchFamily="49" charset="0"/>
+              </a:rPr>
+              <a:t>    </a:t>
+            </a:r>
+            <a:r>
+              <a:rPr lang="en-US" b="0" dirty="0" err="1">
+                <a:solidFill>
+                  <a:srgbClr val="001080"/>
+                </a:solidFill>
+                <a:effectLst/>
+                <a:latin typeface="Consolas" panose="020B0609020204030204" pitchFamily="49" charset="0"/>
+              </a:rPr>
+              <a:t>mock_response</a:t>
+            </a:r>
+            <a:r>
+              <a:rPr lang="en-US" b="0" dirty="0">
+                <a:solidFill>
+                  <a:srgbClr val="000000"/>
+                </a:solidFill>
+                <a:effectLst/>
+                <a:latin typeface="Consolas" panose="020B0609020204030204" pitchFamily="49" charset="0"/>
+              </a:rPr>
+              <a:t> = </a:t>
+            </a:r>
+            <a:r>
+              <a:rPr lang="en-US" b="0" dirty="0" err="1">
+                <a:solidFill>
+                  <a:srgbClr val="001080"/>
+                </a:solidFill>
+                <a:effectLst/>
+                <a:latin typeface="Consolas" panose="020B0609020204030204" pitchFamily="49" charset="0"/>
+              </a:rPr>
+              <a:t>mocker</a:t>
+            </a:r>
+            <a:r>
+              <a:rPr lang="en-US" b="0" dirty="0" err="1">
+                <a:solidFill>
+                  <a:srgbClr val="000000"/>
+                </a:solidFill>
+                <a:effectLst/>
+                <a:latin typeface="Consolas" panose="020B0609020204030204" pitchFamily="49" charset="0"/>
+              </a:rPr>
+              <a:t>.Mock</a:t>
+            </a:r>
+            <a:r>
+              <a:rPr lang="en-US" b="0" dirty="0">
+                <a:solidFill>
+                  <a:srgbClr val="000000"/>
+                </a:solidFill>
+                <a:effectLst/>
+                <a:latin typeface="Consolas" panose="020B0609020204030204" pitchFamily="49" charset="0"/>
+              </a:rPr>
+              <a:t>()</a:t>
+            </a:r>
+          </a:p>
+          <a:p>
+            <a:pPr>
+              <a:lnSpc>
+                <a:spcPts val="1425"/>
+              </a:lnSpc>
+              <a:buNone/>
+            </a:pPr>
+            <a:r>
+              <a:rPr lang="en-US" b="0" dirty="0">
+                <a:solidFill>
+                  <a:srgbClr val="000000"/>
+                </a:solidFill>
+                <a:effectLst/>
+                <a:latin typeface="Consolas" panose="020B0609020204030204" pitchFamily="49" charset="0"/>
+              </a:rPr>
+              <a:t>    </a:t>
+            </a:r>
+            <a:r>
+              <a:rPr lang="en-US" b="0" dirty="0" err="1">
+                <a:solidFill>
+                  <a:srgbClr val="001080"/>
+                </a:solidFill>
+                <a:effectLst/>
+                <a:latin typeface="Consolas" panose="020B0609020204030204" pitchFamily="49" charset="0"/>
+              </a:rPr>
+              <a:t>mock_response</a:t>
+            </a:r>
+            <a:r>
+              <a:rPr lang="en-US" b="0" dirty="0" err="1">
+                <a:solidFill>
+                  <a:srgbClr val="000000"/>
+                </a:solidFill>
+                <a:effectLst/>
+                <a:latin typeface="Consolas" panose="020B0609020204030204" pitchFamily="49" charset="0"/>
+              </a:rPr>
+              <a:t>.status_code</a:t>
+            </a:r>
+            <a:r>
+              <a:rPr lang="en-US" b="0" dirty="0">
+                <a:solidFill>
+                  <a:srgbClr val="000000"/>
+                </a:solidFill>
+                <a:effectLst/>
+                <a:latin typeface="Consolas" panose="020B0609020204030204" pitchFamily="49" charset="0"/>
+              </a:rPr>
+              <a:t> = </a:t>
+            </a:r>
+            <a:r>
+              <a:rPr lang="en-US" b="0" dirty="0">
+                <a:solidFill>
+                  <a:srgbClr val="098658"/>
+                </a:solidFill>
+                <a:effectLst/>
+                <a:latin typeface="Consolas" panose="020B0609020204030204" pitchFamily="49" charset="0"/>
+              </a:rPr>
+              <a:t>200</a:t>
+            </a:r>
+            <a:endParaRPr lang="en-US" b="0" dirty="0">
+              <a:solidFill>
+                <a:srgbClr val="000000"/>
+              </a:solidFill>
+              <a:effectLst/>
+              <a:latin typeface="Consolas" panose="020B0609020204030204" pitchFamily="49" charset="0"/>
+            </a:endParaRPr>
+          </a:p>
+          <a:p>
+            <a:pPr>
+              <a:lnSpc>
+                <a:spcPts val="1425"/>
+              </a:lnSpc>
+              <a:buNone/>
+            </a:pPr>
+            <a:r>
+              <a:rPr lang="en-US" b="0" dirty="0">
+                <a:solidFill>
+                  <a:srgbClr val="000000"/>
+                </a:solidFill>
+                <a:effectLst/>
+                <a:latin typeface="Consolas" panose="020B0609020204030204" pitchFamily="49" charset="0"/>
+              </a:rPr>
+              <a:t>    </a:t>
+            </a:r>
+            <a:r>
+              <a:rPr lang="en-US" b="0" dirty="0" err="1">
+                <a:solidFill>
+                  <a:srgbClr val="001080"/>
+                </a:solidFill>
+                <a:effectLst/>
+                <a:latin typeface="Consolas" panose="020B0609020204030204" pitchFamily="49" charset="0"/>
+              </a:rPr>
+              <a:t>mock_response</a:t>
+            </a:r>
+            <a:r>
+              <a:rPr lang="en-US" b="0" dirty="0" err="1">
+                <a:solidFill>
+                  <a:srgbClr val="000000"/>
+                </a:solidFill>
+                <a:effectLst/>
+                <a:latin typeface="Consolas" panose="020B0609020204030204" pitchFamily="49" charset="0"/>
+              </a:rPr>
+              <a:t>.json.return_value</a:t>
+            </a:r>
+            <a:r>
+              <a:rPr lang="en-US" b="0" dirty="0">
+                <a:solidFill>
+                  <a:srgbClr val="000000"/>
+                </a:solidFill>
+                <a:effectLst/>
+                <a:latin typeface="Consolas" panose="020B0609020204030204" pitchFamily="49" charset="0"/>
+              </a:rPr>
+              <a:t> = {</a:t>
+            </a:r>
+            <a:r>
+              <a:rPr lang="en-US" b="0" dirty="0">
+                <a:solidFill>
+                  <a:srgbClr val="A31515"/>
+                </a:solidFill>
+                <a:effectLst/>
+                <a:latin typeface="Consolas" panose="020B0609020204030204" pitchFamily="49" charset="0"/>
+              </a:rPr>
+              <a:t>"name"</a:t>
+            </a:r>
+            <a:r>
+              <a:rPr lang="en-US" b="0" dirty="0">
+                <a:solidFill>
+                  <a:srgbClr val="000000"/>
+                </a:solidFill>
+                <a:effectLst/>
+                <a:latin typeface="Consolas" panose="020B0609020204030204" pitchFamily="49" charset="0"/>
+              </a:rPr>
+              <a:t>: </a:t>
+            </a:r>
+            <a:r>
+              <a:rPr lang="en-US" b="0" dirty="0">
+                <a:solidFill>
+                  <a:srgbClr val="A31515"/>
+                </a:solidFill>
+                <a:effectLst/>
+                <a:latin typeface="Consolas" panose="020B0609020204030204" pitchFamily="49" charset="0"/>
+              </a:rPr>
+              <a:t>"Alice"</a:t>
+            </a:r>
+            <a:r>
+              <a:rPr lang="en-US" b="0" dirty="0">
+                <a:solidFill>
+                  <a:srgbClr val="000000"/>
+                </a:solidFill>
+                <a:effectLst/>
+                <a:latin typeface="Consolas" panose="020B0609020204030204" pitchFamily="49" charset="0"/>
+              </a:rPr>
+              <a:t>}</a:t>
+            </a:r>
+            <a:br>
+              <a:rPr lang="en-US" b="0" dirty="0">
+                <a:solidFill>
+                  <a:srgbClr val="000000"/>
+                </a:solidFill>
+                <a:effectLst/>
+                <a:latin typeface="Consolas" panose="020B0609020204030204" pitchFamily="49" charset="0"/>
+              </a:rPr>
+            </a:br>
+            <a:endParaRPr lang="en-US" b="0" dirty="0">
+              <a:solidFill>
+                <a:srgbClr val="000000"/>
+              </a:solidFill>
+              <a:effectLst/>
+              <a:latin typeface="Consolas" panose="020B0609020204030204" pitchFamily="49" charset="0"/>
+            </a:endParaRPr>
+          </a:p>
+          <a:p>
+            <a:pPr>
+              <a:lnSpc>
+                <a:spcPts val="1425"/>
+              </a:lnSpc>
+              <a:buNone/>
+            </a:pPr>
+            <a:r>
+              <a:rPr lang="en-US" b="0" dirty="0">
+                <a:solidFill>
+                  <a:srgbClr val="000000"/>
+                </a:solidFill>
+                <a:effectLst/>
+                <a:latin typeface="Consolas" panose="020B0609020204030204" pitchFamily="49" charset="0"/>
+              </a:rPr>
+              <a:t>    </a:t>
+            </a:r>
+            <a:r>
+              <a:rPr lang="en-US" b="0" dirty="0">
+                <a:solidFill>
+                  <a:srgbClr val="008000"/>
+                </a:solidFill>
+                <a:effectLst/>
+                <a:latin typeface="Consolas" panose="020B0609020204030204" pitchFamily="49" charset="0"/>
+              </a:rPr>
+              <a:t># Patch </a:t>
+            </a:r>
+            <a:r>
+              <a:rPr lang="en-US" b="0" dirty="0" err="1">
+                <a:solidFill>
+                  <a:srgbClr val="008000"/>
+                </a:solidFill>
+                <a:effectLst/>
+                <a:latin typeface="Consolas" panose="020B0609020204030204" pitchFamily="49" charset="0"/>
+              </a:rPr>
+              <a:t>requests.get</a:t>
+            </a:r>
+            <a:r>
+              <a:rPr lang="en-US" b="0" dirty="0">
+                <a:solidFill>
+                  <a:srgbClr val="008000"/>
+                </a:solidFill>
+                <a:effectLst/>
+                <a:latin typeface="Consolas" panose="020B0609020204030204" pitchFamily="49" charset="0"/>
+              </a:rPr>
+              <a:t> to return our mock response</a:t>
+            </a:r>
+            <a:endParaRPr lang="en-US" b="0" dirty="0">
+              <a:solidFill>
+                <a:srgbClr val="000000"/>
+              </a:solidFill>
+              <a:effectLst/>
+              <a:latin typeface="Consolas" panose="020B0609020204030204" pitchFamily="49" charset="0"/>
+            </a:endParaRPr>
+          </a:p>
+          <a:p>
+            <a:pPr>
+              <a:lnSpc>
+                <a:spcPts val="1425"/>
+              </a:lnSpc>
+              <a:buNone/>
+            </a:pPr>
+            <a:r>
+              <a:rPr lang="en-US" b="0" dirty="0">
+                <a:solidFill>
+                  <a:srgbClr val="000000"/>
+                </a:solidFill>
+                <a:effectLst/>
+                <a:latin typeface="Consolas" panose="020B0609020204030204" pitchFamily="49" charset="0"/>
+              </a:rPr>
+              <a:t>    </a:t>
+            </a:r>
+            <a:r>
+              <a:rPr lang="en-US" b="0" dirty="0" err="1">
+                <a:solidFill>
+                  <a:srgbClr val="001080"/>
+                </a:solidFill>
+                <a:effectLst/>
+                <a:latin typeface="Consolas" panose="020B0609020204030204" pitchFamily="49" charset="0"/>
+              </a:rPr>
+              <a:t>mocker</a:t>
+            </a:r>
+            <a:r>
+              <a:rPr lang="en-US" b="0" dirty="0" err="1">
+                <a:solidFill>
+                  <a:srgbClr val="000000"/>
+                </a:solidFill>
+                <a:effectLst/>
+                <a:latin typeface="Consolas" panose="020B0609020204030204" pitchFamily="49" charset="0"/>
+              </a:rPr>
+              <a:t>.patch</a:t>
+            </a:r>
+            <a:r>
+              <a:rPr lang="en-US" b="0" dirty="0">
+                <a:solidFill>
+                  <a:srgbClr val="000000"/>
+                </a:solidFill>
+                <a:effectLst/>
+                <a:latin typeface="Consolas" panose="020B0609020204030204" pitchFamily="49" charset="0"/>
+              </a:rPr>
+              <a:t>(</a:t>
+            </a:r>
+            <a:r>
+              <a:rPr lang="en-US" b="0" dirty="0">
+                <a:solidFill>
+                  <a:srgbClr val="A31515"/>
+                </a:solidFill>
+                <a:effectLst/>
+                <a:latin typeface="Consolas" panose="020B0609020204030204" pitchFamily="49" charset="0"/>
+              </a:rPr>
+              <a:t>"</a:t>
+            </a:r>
+            <a:r>
+              <a:rPr lang="en-US" b="0" dirty="0" err="1">
+                <a:solidFill>
+                  <a:srgbClr val="A31515"/>
+                </a:solidFill>
+                <a:effectLst/>
+                <a:latin typeface="Consolas" panose="020B0609020204030204" pitchFamily="49" charset="0"/>
+              </a:rPr>
+              <a:t>app.requests.get</a:t>
+            </a:r>
+            <a:r>
+              <a:rPr lang="en-US" b="0" dirty="0">
+                <a:solidFill>
+                  <a:srgbClr val="A31515"/>
+                </a:solidFill>
+                <a:effectLst/>
+                <a:latin typeface="Consolas" panose="020B0609020204030204" pitchFamily="49" charset="0"/>
+              </a:rPr>
+              <a:t>"</a:t>
+            </a:r>
+            <a:r>
+              <a:rPr lang="en-US" b="0" dirty="0">
+                <a:solidFill>
+                  <a:srgbClr val="000000"/>
+                </a:solidFill>
+                <a:effectLst/>
+                <a:latin typeface="Consolas" panose="020B0609020204030204" pitchFamily="49" charset="0"/>
+              </a:rPr>
+              <a:t>, </a:t>
+            </a:r>
+            <a:r>
+              <a:rPr lang="en-US" b="0" dirty="0" err="1">
+                <a:solidFill>
+                  <a:srgbClr val="001080"/>
+                </a:solidFill>
+                <a:effectLst/>
+                <a:latin typeface="Consolas" panose="020B0609020204030204" pitchFamily="49" charset="0"/>
+              </a:rPr>
+              <a:t>return_value</a:t>
+            </a:r>
+            <a:r>
+              <a:rPr lang="en-US" b="0" dirty="0">
+                <a:solidFill>
+                  <a:srgbClr val="000000"/>
+                </a:solidFill>
+                <a:effectLst/>
+                <a:latin typeface="Consolas" panose="020B0609020204030204" pitchFamily="49" charset="0"/>
+              </a:rPr>
+              <a:t>=</a:t>
+            </a:r>
+            <a:r>
+              <a:rPr lang="en-US" b="0" dirty="0" err="1">
+                <a:solidFill>
+                  <a:srgbClr val="001080"/>
+                </a:solidFill>
+                <a:effectLst/>
+                <a:latin typeface="Consolas" panose="020B0609020204030204" pitchFamily="49" charset="0"/>
+              </a:rPr>
+              <a:t>mock_response</a:t>
+            </a:r>
+            <a:r>
+              <a:rPr lang="en-US" b="0" dirty="0">
+                <a:solidFill>
+                  <a:srgbClr val="000000"/>
+                </a:solidFill>
+                <a:effectLst/>
+                <a:latin typeface="Consolas" panose="020B0609020204030204" pitchFamily="49" charset="0"/>
+              </a:rPr>
+              <a:t>)</a:t>
+            </a:r>
+            <a:br>
+              <a:rPr lang="en-US" b="0" dirty="0">
+                <a:solidFill>
+                  <a:srgbClr val="000000"/>
+                </a:solidFill>
+                <a:effectLst/>
+                <a:latin typeface="Consolas" panose="020B0609020204030204" pitchFamily="49" charset="0"/>
+              </a:rPr>
+            </a:br>
+            <a:endParaRPr lang="en-US" b="0" dirty="0">
+              <a:solidFill>
+                <a:srgbClr val="000000"/>
+              </a:solidFill>
+              <a:effectLst/>
+              <a:latin typeface="Consolas" panose="020B0609020204030204" pitchFamily="49" charset="0"/>
+            </a:endParaRPr>
+          </a:p>
+          <a:p>
+            <a:pPr>
+              <a:lnSpc>
+                <a:spcPts val="1425"/>
+              </a:lnSpc>
+              <a:buNone/>
+            </a:pPr>
+            <a:r>
+              <a:rPr lang="en-US" b="0" dirty="0">
+                <a:solidFill>
+                  <a:srgbClr val="000000"/>
+                </a:solidFill>
+                <a:effectLst/>
+                <a:latin typeface="Consolas" panose="020B0609020204030204" pitchFamily="49" charset="0"/>
+              </a:rPr>
+              <a:t>    </a:t>
+            </a:r>
+            <a:r>
+              <a:rPr lang="en-US" b="0" dirty="0">
+                <a:solidFill>
+                  <a:srgbClr val="008000"/>
+                </a:solidFill>
+                <a:effectLst/>
+                <a:latin typeface="Consolas" panose="020B0609020204030204" pitchFamily="49" charset="0"/>
+              </a:rPr>
+              <a:t># Call the function under test</a:t>
+            </a:r>
+            <a:endParaRPr lang="en-US" b="0" dirty="0">
+              <a:solidFill>
+                <a:srgbClr val="000000"/>
+              </a:solidFill>
+              <a:effectLst/>
+              <a:latin typeface="Consolas" panose="020B0609020204030204" pitchFamily="49" charset="0"/>
+            </a:endParaRPr>
+          </a:p>
+          <a:p>
+            <a:pPr>
+              <a:lnSpc>
+                <a:spcPts val="1425"/>
+              </a:lnSpc>
+              <a:buNone/>
+            </a:pPr>
+            <a:r>
+              <a:rPr lang="en-US" b="0" dirty="0">
+                <a:solidFill>
+                  <a:srgbClr val="000000"/>
+                </a:solidFill>
+                <a:effectLst/>
+                <a:latin typeface="Consolas" panose="020B0609020204030204" pitchFamily="49" charset="0"/>
+              </a:rPr>
+              <a:t>    </a:t>
+            </a:r>
+            <a:r>
+              <a:rPr lang="en-US" b="0" dirty="0">
+                <a:solidFill>
+                  <a:srgbClr val="001080"/>
+                </a:solidFill>
+                <a:effectLst/>
+                <a:latin typeface="Consolas" panose="020B0609020204030204" pitchFamily="49" charset="0"/>
+              </a:rPr>
+              <a:t>result</a:t>
+            </a:r>
+            <a:r>
+              <a:rPr lang="en-US" b="0" dirty="0">
+                <a:solidFill>
+                  <a:srgbClr val="000000"/>
+                </a:solidFill>
+                <a:effectLst/>
+                <a:latin typeface="Consolas" panose="020B0609020204030204" pitchFamily="49" charset="0"/>
+              </a:rPr>
+              <a:t> = </a:t>
+            </a:r>
+            <a:r>
+              <a:rPr lang="en-US" b="0" dirty="0" err="1">
+                <a:solidFill>
+                  <a:srgbClr val="000000"/>
+                </a:solidFill>
+                <a:effectLst/>
+                <a:latin typeface="Consolas" panose="020B0609020204030204" pitchFamily="49" charset="0"/>
+              </a:rPr>
+              <a:t>get_user_name</a:t>
+            </a:r>
+            <a:r>
+              <a:rPr lang="en-US" b="0" dirty="0">
+                <a:solidFill>
+                  <a:srgbClr val="000000"/>
+                </a:solidFill>
+                <a:effectLst/>
+                <a:latin typeface="Consolas" panose="020B0609020204030204" pitchFamily="49" charset="0"/>
+              </a:rPr>
+              <a:t>(</a:t>
+            </a:r>
+            <a:r>
+              <a:rPr lang="en-US" b="0" dirty="0">
+                <a:solidFill>
+                  <a:srgbClr val="098658"/>
+                </a:solidFill>
+                <a:effectLst/>
+                <a:latin typeface="Consolas" panose="020B0609020204030204" pitchFamily="49" charset="0"/>
+              </a:rPr>
+              <a:t>123</a:t>
+            </a:r>
+            <a:r>
+              <a:rPr lang="en-US" b="0" dirty="0">
+                <a:solidFill>
+                  <a:srgbClr val="000000"/>
+                </a:solidFill>
+                <a:effectLst/>
+                <a:latin typeface="Consolas" panose="020B0609020204030204" pitchFamily="49" charset="0"/>
+              </a:rPr>
+              <a:t>)</a:t>
+            </a:r>
+            <a:br>
+              <a:rPr lang="en-US" b="0" dirty="0">
+                <a:solidFill>
+                  <a:srgbClr val="000000"/>
+                </a:solidFill>
+                <a:effectLst/>
+                <a:latin typeface="Consolas" panose="020B0609020204030204" pitchFamily="49" charset="0"/>
+              </a:rPr>
+            </a:br>
+            <a:endParaRPr lang="en-US" b="0" dirty="0">
+              <a:solidFill>
+                <a:srgbClr val="000000"/>
+              </a:solidFill>
+              <a:effectLst/>
+              <a:latin typeface="Consolas" panose="020B0609020204030204" pitchFamily="49" charset="0"/>
+            </a:endParaRPr>
+          </a:p>
+          <a:p>
+            <a:pPr>
+              <a:lnSpc>
+                <a:spcPts val="1425"/>
+              </a:lnSpc>
+              <a:buNone/>
+            </a:pPr>
+            <a:r>
+              <a:rPr lang="en-US" b="0" dirty="0">
+                <a:solidFill>
+                  <a:srgbClr val="000000"/>
+                </a:solidFill>
+                <a:effectLst/>
+                <a:latin typeface="Consolas" panose="020B0609020204030204" pitchFamily="49" charset="0"/>
+              </a:rPr>
+              <a:t>    </a:t>
+            </a:r>
+            <a:r>
+              <a:rPr lang="en-US" b="0" dirty="0">
+                <a:solidFill>
+                  <a:srgbClr val="008000"/>
+                </a:solidFill>
+                <a:effectLst/>
+                <a:latin typeface="Consolas" panose="020B0609020204030204" pitchFamily="49" charset="0"/>
+              </a:rPr>
+              <a:t># Assertions</a:t>
+            </a:r>
+            <a:endParaRPr lang="en-US" b="0" dirty="0">
+              <a:solidFill>
+                <a:srgbClr val="000000"/>
+              </a:solidFill>
+              <a:effectLst/>
+              <a:latin typeface="Consolas" panose="020B0609020204030204" pitchFamily="49" charset="0"/>
+            </a:endParaRPr>
+          </a:p>
+          <a:p>
+            <a:pPr>
+              <a:lnSpc>
+                <a:spcPts val="1425"/>
+              </a:lnSpc>
+              <a:buNone/>
+            </a:pPr>
+            <a:r>
+              <a:rPr lang="en-US" b="0" dirty="0">
+                <a:solidFill>
+                  <a:srgbClr val="000000"/>
+                </a:solidFill>
+                <a:effectLst/>
+                <a:latin typeface="Consolas" panose="020B0609020204030204" pitchFamily="49" charset="0"/>
+              </a:rPr>
+              <a:t>    </a:t>
+            </a:r>
+            <a:r>
+              <a:rPr lang="en-US" b="0" dirty="0">
+                <a:solidFill>
+                  <a:srgbClr val="AF00DB"/>
+                </a:solidFill>
+                <a:effectLst/>
+                <a:latin typeface="Consolas" panose="020B0609020204030204" pitchFamily="49" charset="0"/>
+              </a:rPr>
+              <a:t>assert</a:t>
+            </a:r>
+            <a:r>
+              <a:rPr lang="en-US" b="0" dirty="0">
+                <a:solidFill>
+                  <a:srgbClr val="000000"/>
+                </a:solidFill>
+                <a:effectLst/>
+                <a:latin typeface="Consolas" panose="020B0609020204030204" pitchFamily="49" charset="0"/>
+              </a:rPr>
+              <a:t> </a:t>
+            </a:r>
+            <a:r>
+              <a:rPr lang="en-US" b="0" dirty="0">
+                <a:solidFill>
+                  <a:srgbClr val="001080"/>
+                </a:solidFill>
+                <a:effectLst/>
+                <a:latin typeface="Consolas" panose="020B0609020204030204" pitchFamily="49" charset="0"/>
+              </a:rPr>
+              <a:t>result</a:t>
+            </a:r>
+            <a:r>
+              <a:rPr lang="en-US" b="0" dirty="0">
+                <a:solidFill>
+                  <a:srgbClr val="000000"/>
+                </a:solidFill>
+                <a:effectLst/>
+                <a:latin typeface="Consolas" panose="020B0609020204030204" pitchFamily="49" charset="0"/>
+              </a:rPr>
+              <a:t> == </a:t>
+            </a:r>
+            <a:r>
+              <a:rPr lang="en-US" b="0" dirty="0">
+                <a:solidFill>
+                  <a:srgbClr val="A31515"/>
+                </a:solidFill>
+                <a:effectLst/>
+                <a:latin typeface="Consolas" panose="020B0609020204030204" pitchFamily="49" charset="0"/>
+              </a:rPr>
+              <a:t>"Alice"</a:t>
+            </a:r>
+            <a:endParaRPr lang="en-US" b="0" dirty="0">
+              <a:solidFill>
+                <a:srgbClr val="000000"/>
+              </a:solidFill>
+              <a:effectLst/>
+              <a:latin typeface="Consolas" panose="020B0609020204030204" pitchFamily="49" charset="0"/>
+            </a:endParaRPr>
+          </a:p>
+          <a:p>
+            <a:pPr>
+              <a:lnSpc>
+                <a:spcPts val="1425"/>
+              </a:lnSpc>
+              <a:buNone/>
+            </a:pPr>
+            <a:r>
+              <a:rPr lang="en-US" b="0" dirty="0">
+                <a:solidFill>
+                  <a:srgbClr val="000000"/>
+                </a:solidFill>
+                <a:effectLst/>
+                <a:latin typeface="Consolas" panose="020B0609020204030204" pitchFamily="49" charset="0"/>
+              </a:rPr>
+              <a:t>    </a:t>
+            </a:r>
+            <a:r>
+              <a:rPr lang="en-US" b="0" dirty="0" err="1">
+                <a:solidFill>
+                  <a:srgbClr val="001080"/>
+                </a:solidFill>
+                <a:effectLst/>
+                <a:latin typeface="Consolas" panose="020B0609020204030204" pitchFamily="49" charset="0"/>
+              </a:rPr>
+              <a:t>app_requests_get</a:t>
+            </a:r>
+            <a:r>
+              <a:rPr lang="en-US" b="0" dirty="0">
+                <a:solidFill>
+                  <a:srgbClr val="000000"/>
+                </a:solidFill>
+                <a:effectLst/>
+                <a:latin typeface="Consolas" panose="020B0609020204030204" pitchFamily="49" charset="0"/>
+              </a:rPr>
+              <a:t> = </a:t>
+            </a:r>
+            <a:r>
+              <a:rPr lang="en-US" b="0" dirty="0" err="1">
+                <a:solidFill>
+                  <a:srgbClr val="001080"/>
+                </a:solidFill>
+                <a:effectLst/>
+                <a:latin typeface="Consolas" panose="020B0609020204030204" pitchFamily="49" charset="0"/>
+              </a:rPr>
+              <a:t>mocker</a:t>
+            </a:r>
+            <a:r>
+              <a:rPr lang="en-US" b="0" dirty="0" err="1">
+                <a:solidFill>
+                  <a:srgbClr val="000000"/>
+                </a:solidFill>
+                <a:effectLst/>
+                <a:latin typeface="Consolas" panose="020B0609020204030204" pitchFamily="49" charset="0"/>
+              </a:rPr>
+              <a:t>.patch</a:t>
+            </a:r>
+            <a:r>
+              <a:rPr lang="en-US" b="0" dirty="0">
+                <a:solidFill>
+                  <a:srgbClr val="000000"/>
+                </a:solidFill>
+                <a:effectLst/>
+                <a:latin typeface="Consolas" panose="020B0609020204030204" pitchFamily="49" charset="0"/>
+              </a:rPr>
+              <a:t>(</a:t>
+            </a:r>
+            <a:r>
+              <a:rPr lang="en-US" b="0" dirty="0">
+                <a:solidFill>
+                  <a:srgbClr val="A31515"/>
+                </a:solidFill>
+                <a:effectLst/>
+                <a:latin typeface="Consolas" panose="020B0609020204030204" pitchFamily="49" charset="0"/>
+              </a:rPr>
+              <a:t>"</a:t>
+            </a:r>
+            <a:r>
+              <a:rPr lang="en-US" b="0" dirty="0" err="1">
+                <a:solidFill>
+                  <a:srgbClr val="A31515"/>
+                </a:solidFill>
+                <a:effectLst/>
+                <a:latin typeface="Consolas" panose="020B0609020204030204" pitchFamily="49" charset="0"/>
+              </a:rPr>
+              <a:t>app.requests.get</a:t>
+            </a:r>
+            <a:r>
+              <a:rPr lang="en-US" b="0" dirty="0">
+                <a:solidFill>
+                  <a:srgbClr val="A31515"/>
+                </a:solidFill>
+                <a:effectLst/>
+                <a:latin typeface="Consolas" panose="020B0609020204030204" pitchFamily="49" charset="0"/>
+              </a:rPr>
+              <a:t>"</a:t>
+            </a:r>
+            <a:r>
+              <a:rPr lang="en-US" b="0" dirty="0">
+                <a:solidFill>
+                  <a:srgbClr val="000000"/>
+                </a:solidFill>
+                <a:effectLst/>
+                <a:latin typeface="Consolas" panose="020B0609020204030204" pitchFamily="49" charset="0"/>
+              </a:rPr>
+              <a:t>)</a:t>
+            </a:r>
+          </a:p>
+          <a:p>
+            <a:pPr>
+              <a:lnSpc>
+                <a:spcPts val="1425"/>
+              </a:lnSpc>
+              <a:buNone/>
+            </a:pPr>
+            <a:r>
+              <a:rPr lang="en-US" b="0" dirty="0">
+                <a:solidFill>
+                  <a:srgbClr val="000000"/>
+                </a:solidFill>
+                <a:effectLst/>
+                <a:latin typeface="Consolas" panose="020B0609020204030204" pitchFamily="49" charset="0"/>
+              </a:rPr>
+              <a:t>    </a:t>
+            </a:r>
+            <a:r>
+              <a:rPr lang="en-US" b="0" dirty="0" err="1">
+                <a:solidFill>
+                  <a:srgbClr val="001080"/>
+                </a:solidFill>
+                <a:effectLst/>
+                <a:latin typeface="Consolas" panose="020B0609020204030204" pitchFamily="49" charset="0"/>
+              </a:rPr>
+              <a:t>app_requests_get</a:t>
+            </a:r>
+            <a:r>
+              <a:rPr lang="en-US" b="0" dirty="0" err="1">
+                <a:solidFill>
+                  <a:srgbClr val="000000"/>
+                </a:solidFill>
+                <a:effectLst/>
+                <a:latin typeface="Consolas" panose="020B0609020204030204" pitchFamily="49" charset="0"/>
+              </a:rPr>
+              <a:t>.assert_called_once_with</a:t>
+            </a:r>
+            <a:r>
+              <a:rPr lang="en-US" b="0" dirty="0">
+                <a:solidFill>
+                  <a:srgbClr val="000000"/>
+                </a:solidFill>
+                <a:effectLst/>
+                <a:latin typeface="Consolas" panose="020B0609020204030204" pitchFamily="49" charset="0"/>
+              </a:rPr>
+              <a:t>(</a:t>
+            </a:r>
+            <a:r>
+              <a:rPr lang="en-US" b="0" dirty="0">
+                <a:solidFill>
+                  <a:srgbClr val="A31515"/>
+                </a:solidFill>
+                <a:effectLst/>
+                <a:latin typeface="Consolas" panose="020B0609020204030204" pitchFamily="49" charset="0"/>
+              </a:rPr>
+              <a:t>"https://api.example.com/users/123"</a:t>
+            </a:r>
+            <a:r>
+              <a:rPr lang="en-US" b="0" dirty="0">
+                <a:solidFill>
+                  <a:srgbClr val="000000"/>
+                </a:solidFill>
+                <a:effectLst/>
+                <a:latin typeface="Consolas" panose="020B0609020204030204" pitchFamily="49" charset="0"/>
+              </a:rPr>
+              <a:t>)</a:t>
+            </a:r>
+          </a:p>
+          <a:p>
+            <a:pPr>
+              <a:lnSpc>
+                <a:spcPts val="1425"/>
+              </a:lnSpc>
+              <a:buNone/>
+            </a:pPr>
+            <a:br>
+              <a:rPr lang="en-US" b="0" dirty="0">
+                <a:solidFill>
+                  <a:srgbClr val="000000"/>
+                </a:solidFill>
+                <a:effectLst/>
+                <a:latin typeface="Consolas" panose="020B0609020204030204" pitchFamily="49" charset="0"/>
+              </a:rPr>
+            </a:br>
+            <a:endParaRPr lang="en-US" b="0" dirty="0">
+              <a:solidFill>
+                <a:srgbClr val="000000"/>
+              </a:solidFill>
+              <a:effectLst/>
+              <a:latin typeface="Consolas" panose="020B0609020204030204" pitchFamily="49" charset="0"/>
+            </a:endParaRPr>
+          </a:p>
+        </p:txBody>
+      </p:sp>
+    </p:spTree>
+    <p:extLst>
+      <p:ext uri="{BB962C8B-B14F-4D97-AF65-F5344CB8AC3E}">
+        <p14:creationId xmlns:p14="http://schemas.microsoft.com/office/powerpoint/2010/main" val="4277585709"/>
+      </p:ext>
+    </p:extLst>
+  </p:cSld>
+  <p:clrMapOvr>
+    <a:masterClrMapping/>
+  </p:clrMapOvr>
+</p:sld>
+</file>
+
+<file path=ppt/slides/slide24.xml><?xml version="1.0" encoding="utf-8"?>
+<p:sld xmlns:a="http://schemas.openxmlformats.org/drawingml/2006/main" xmlns:r="http://schemas.openxmlformats.org/officeDocument/2006/relationships" xmlns:p="http://schemas.openxmlformats.org/presentationml/2006/main">
+  <p:cSld>
+    <p:spTree>
+      <p:nvGrpSpPr>
+        <p:cNvPr id="1" name="">
+          <a:extLst>
+            <a:ext uri="{FF2B5EF4-FFF2-40B4-BE49-F238E27FC236}">
+              <a16:creationId xmlns:a16="http://schemas.microsoft.com/office/drawing/2014/main" id="{A2DC3137-EE76-F4BD-9363-EE66EBBB6BC8}"/>
+            </a:ext>
+          </a:extLst>
+        </p:cNvPr>
+        <p:cNvGrpSpPr/>
+        <p:nvPr/>
+      </p:nvGrpSpPr>
+      <p:grpSpPr>
+        <a:xfrm>
+          <a:off x="0" y="0"/>
+          <a:ext cx="0" cy="0"/>
+          <a:chOff x="0" y="0"/>
+          <a:chExt cx="0" cy="0"/>
+        </a:xfrm>
+      </p:grpSpPr>
+      <p:sp>
+        <p:nvSpPr>
+          <p:cNvPr id="7" name="Title 6">
+            <a:extLst>
+              <a:ext uri="{FF2B5EF4-FFF2-40B4-BE49-F238E27FC236}">
+                <a16:creationId xmlns:a16="http://schemas.microsoft.com/office/drawing/2014/main" id="{6475912A-B09E-D7AA-BF2E-B85E1D93DE10}"/>
+              </a:ext>
+            </a:extLst>
+          </p:cNvPr>
+          <p:cNvSpPr>
+            <a:spLocks noGrp="1"/>
+          </p:cNvSpPr>
+          <p:nvPr>
+            <p:ph type="ctrTitle"/>
+          </p:nvPr>
+        </p:nvSpPr>
+        <p:spPr/>
+        <p:txBody>
+          <a:bodyPr/>
+          <a:lstStyle/>
+          <a:p>
+            <a:r>
+              <a:rPr lang="en-US" dirty="0"/>
+              <a:t>Hands-On #2</a:t>
+            </a:r>
+          </a:p>
+        </p:txBody>
+      </p:sp>
+      <p:sp>
+        <p:nvSpPr>
+          <p:cNvPr id="8" name="Subtitle 7">
+            <a:extLst>
+              <a:ext uri="{FF2B5EF4-FFF2-40B4-BE49-F238E27FC236}">
+                <a16:creationId xmlns:a16="http://schemas.microsoft.com/office/drawing/2014/main" id="{C38F5AAB-5F11-E345-0D62-9631ED1D55DC}"/>
+              </a:ext>
+            </a:extLst>
+          </p:cNvPr>
+          <p:cNvSpPr>
+            <a:spLocks noGrp="1"/>
+          </p:cNvSpPr>
+          <p:nvPr>
+            <p:ph type="subTitle" idx="1"/>
+          </p:nvPr>
+        </p:nvSpPr>
+        <p:spPr/>
+        <p:txBody>
+          <a:bodyPr/>
+          <a:lstStyle/>
+          <a:p>
+            <a:endParaRPr lang="en-US"/>
+          </a:p>
+        </p:txBody>
+      </p:sp>
+      <p:sp>
+        <p:nvSpPr>
+          <p:cNvPr id="5" name="Date Placeholder 4">
+            <a:extLst>
+              <a:ext uri="{FF2B5EF4-FFF2-40B4-BE49-F238E27FC236}">
+                <a16:creationId xmlns:a16="http://schemas.microsoft.com/office/drawing/2014/main" id="{E82267A7-C484-C83E-8B82-9CF82CE72D5B}"/>
+              </a:ext>
+            </a:extLst>
+          </p:cNvPr>
+          <p:cNvSpPr>
+            <a:spLocks noGrp="1"/>
+          </p:cNvSpPr>
+          <p:nvPr>
+            <p:ph type="dt" idx="10"/>
+          </p:nvPr>
+        </p:nvSpPr>
+        <p:spPr/>
+        <p:txBody>
+          <a:bodyPr/>
+          <a:lstStyle/>
+          <a:p>
+            <a:fld id="{334F72C3-CDF3-44A8-B602-1649B1728485}" type="datetime3">
+              <a:rPr lang="en-US" smtClean="0"/>
+              <a:t>18 June 2026</a:t>
+            </a:fld>
+            <a:endParaRPr lang="en-US"/>
+          </a:p>
+        </p:txBody>
+      </p:sp>
+      <p:sp>
+        <p:nvSpPr>
+          <p:cNvPr id="6" name="Slide Number Placeholder 5">
+            <a:extLst>
+              <a:ext uri="{FF2B5EF4-FFF2-40B4-BE49-F238E27FC236}">
+                <a16:creationId xmlns:a16="http://schemas.microsoft.com/office/drawing/2014/main" id="{908D7289-0998-CE75-D9FB-F16435D97F32}"/>
+              </a:ext>
+            </a:extLst>
+          </p:cNvPr>
+          <p:cNvSpPr>
+            <a:spLocks noGrp="1"/>
+          </p:cNvSpPr>
+          <p:nvPr>
+            <p:ph type="sldNum" idx="12"/>
+          </p:nvPr>
+        </p:nvSpPr>
+        <p:spPr/>
+        <p:txBody>
+          <a:bodyPr/>
+          <a:lstStyle/>
+          <a:p>
+            <a:fld id="{64E5BE4B-2FBF-4174-9E62-85FAD1CB43A6}" type="slidenum">
+              <a:rPr lang="en-US" smtClean="0"/>
+              <a:pPr/>
+              <a:t>24</a:t>
+            </a:fld>
+            <a:endParaRPr lang="en-US"/>
+          </a:p>
+        </p:txBody>
+      </p:sp>
+    </p:spTree>
+    <p:extLst>
+      <p:ext uri="{BB962C8B-B14F-4D97-AF65-F5344CB8AC3E}">
+        <p14:creationId xmlns:p14="http://schemas.microsoft.com/office/powerpoint/2010/main" val="2858311391"/>
+      </p:ext>
+    </p:extLst>
+  </p:cSld>
+  <p:clrMapOvr>
+    <a:masterClrMapping/>
+  </p:clrMapOvr>
+</p:sld>
+</file>
+
+<file path=ppt/slides/slide25.xml><?xml version="1.0" encoding="utf-8"?>
+<p:sld xmlns:a="http://schemas.openxmlformats.org/drawingml/2006/main" xmlns:r="http://schemas.openxmlformats.org/officeDocument/2006/relationships" xmlns:p="http://schemas.openxmlformats.org/presentationml/2006/main">
+  <p:cSld>
+    <p:spTree>
+      <p:nvGrpSpPr>
+        <p:cNvPr id="1" name=""/>
+        <p:cNvGrpSpPr/>
+        <p:nvPr/>
+      </p:nvGrpSpPr>
+      <p:grpSpPr>
+        <a:xfrm>
+          <a:off x="0" y="0"/>
+          <a:ext cx="0" cy="0"/>
+          <a:chOff x="0" y="0"/>
+          <a:chExt cx="0" cy="0"/>
+        </a:xfrm>
+      </p:grpSpPr>
+      <p:sp>
+        <p:nvSpPr>
           <p:cNvPr id="7" name="Subtitle 6">
             <a:extLst>
               <a:ext uri="{FF2B5EF4-FFF2-40B4-BE49-F238E27FC236}">
@@ -28850,7 +31480,7 @@
           <a:p>
             <a:fld id="{AD622D1A-DF83-41A8-85FF-04D90BF831D3}" type="datetime3">
               <a:rPr lang="en-US" smtClean="0"/>
-              <a:t>16 June 2026</a:t>
+              <a:t>18 June 2026</a:t>
             </a:fld>
             <a:endParaRPr lang="en-US"/>
           </a:p>
@@ -28880,7 +31510,7 @@
             <a:fld id="{64E5BE4B-2FBF-4174-9E62-85FAD1CB43A6}" type="slidenum">
               <a:rPr lang="en-US" smtClean="0"/>
               <a:pPr/>
-              <a:t>22</a:t>
+              <a:t>25</a:t>
             </a:fld>
             <a:endParaRPr lang="en-US"/>
           </a:p>
@@ -28995,7 +31625,7 @@
           <a:p>
             <a:fld id="{AD622D1A-DF83-41A8-85FF-04D90BF831D3}" type="datetime3">
               <a:rPr lang="en-US" smtClean="0"/>
-              <a:t>16 June 2026</a:t>
+              <a:t>18 June 2026</a:t>
             </a:fld>
             <a:endParaRPr lang="en-US"/>
           </a:p>
@@ -29182,7 +31812,7 @@
           <a:p>
             <a:fld id="{AD622D1A-DF83-41A8-85FF-04D90BF831D3}" type="datetime3">
               <a:rPr lang="en-US" smtClean="0"/>
-              <a:t>16 June 2026</a:t>
+              <a:t>18 June 2026</a:t>
             </a:fld>
             <a:endParaRPr lang="en-US"/>
           </a:p>
@@ -29477,7 +32107,7 @@
             <a:fld id="{AD622D1A-DF83-41A8-85FF-04D90BF831D3}" type="datetime3">
               <a:rPr lang="en-US" smtClean="0"/>
               <a:pPr/>
-              <a:t>16 June 2026</a:t>
+              <a:t>18 June 2026</a:t>
             </a:fld>
             <a:endParaRPr lang="en-US"/>
           </a:p>
@@ -29757,7 +32387,7 @@
           <a:p>
             <a:fld id="{AD622D1A-DF83-41A8-85FF-04D90BF831D3}" type="datetime3">
               <a:rPr lang="en-US" smtClean="0"/>
-              <a:t>16 June 2026</a:t>
+              <a:t>18 June 2026</a:t>
             </a:fld>
             <a:endParaRPr lang="en-US"/>
           </a:p>
@@ -29941,7 +32571,7 @@
           <a:p>
             <a:fld id="{AD622D1A-DF83-41A8-85FF-04D90BF831D3}" type="datetime3">
               <a:rPr lang="en-US" smtClean="0"/>
-              <a:t>16 June 2026</a:t>
+              <a:t>18 June 2026</a:t>
             </a:fld>
             <a:endParaRPr lang="en-US"/>
           </a:p>
@@ -30159,7 +32789,7 @@
           <a:p>
             <a:r>
               <a:rPr lang="en-US" dirty="0"/>
-              <a:t>Keep tests small!!</a:t>
+              <a:t>Tests should be independent, reproducible, and small!!</a:t>
             </a:r>
           </a:p>
         </p:txBody>
@@ -30187,7 +32817,7 @@
           <a:p>
             <a:fld id="{AD622D1A-DF83-41A8-85FF-04D90BF831D3}" type="datetime3">
               <a:rPr lang="en-US" smtClean="0"/>
-              <a:t>16 June 2026</a:t>
+              <a:t>18 June 2026</a:t>
             </a:fld>
             <a:endParaRPr lang="en-US"/>
           </a:p>
@@ -30301,7 +32931,7 @@
           <a:p>
             <a:fld id="{AD622D1A-DF83-41A8-85FF-04D90BF831D3}" type="datetime3">
               <a:rPr lang="en-US" smtClean="0"/>
-              <a:t>16 June 2026</a:t>
+              <a:t>18 June 2026</a:t>
             </a:fld>
             <a:endParaRPr lang="en-US"/>
           </a:p>

</xml_diff>